<commit_message>
Add booked jobs to Jan 1 – Oct 23 deck and workbook
Co-Authored-By: Claude Opus 5.5 <noreply@anthropic.com>
Claude-Session: https://claude.ai/code/session_015KGeERGX8tZXyoMsdSGKK4
</commit_message>
<xml_diff>
--- a/Coastal-Air-Plus-YTD-Performance-Oct23-2026.pptx
+++ b/Coastal-Air-Plus-YTD-Performance-Oct23-2026.pptx
@@ -1143,7 +1143,7 @@
           <a:lstStyle/>
           <a:p>
             <a:r>
-              <a:t>Unpaid sources with more than 10 thousand in closed revenue. Charleston GBP alone closed about 214 thousand from 636 unique leads, far ahead of Myrtle Beach GBP.</a:t>
+              <a:t>Unpaid sources with more than 10 thousand in closed revenue. Book rate = booked jobs divided by unique leads. Charleston GBP alone closed about 214 thousand from 636 unique leads, far ahead of Myrtle Beach GBP.</a:t>
             </a:r>
           </a:p>
         </p:txBody>
@@ -4714,7 +4714,7 @@
                           </a:solidFill>
                           <a:latin typeface="Arial"/>
                         </a:rPr>
-                        <a:t>Conv.</a:t>
+                        <a:t>Leads</a:t>
                       </a:r>
                     </a:p>
                   </a:txBody>
@@ -4737,7 +4737,7 @@
                           </a:solidFill>
                           <a:latin typeface="Arial"/>
                         </a:rPr>
-                        <a:t>Leads</a:t>
+                        <a:t>Booked</a:t>
                       </a:r>
                     </a:p>
                   </a:txBody>
@@ -4900,30 +4900,30 @@
                           </a:solidFill>
                           <a:latin typeface="Arial"/>
                         </a:rPr>
-                        <a:t>59</a:t>
-                      </a:r>
-                    </a:p>
-                  </a:txBody>
-                  <a:tcPr marL="73152" marR="73152" marT="27432" marB="27432" anchor="ctr">
-                    <a:solidFill>
-                      <a:srgbClr val="FFFFFF"/>
-                    </a:solidFill>
-                  </a:tcPr>
-                </a:tc>
-                <a:tc>
-                  <a:txBody>
-                    <a:bodyPr wrap="square"/>
-                    <a:lstStyle/>
-                    <a:p>
-                      <a:pPr algn="r"/>
-                      <a:r>
-                        <a:rPr sz="1100" b="0">
-                          <a:solidFill>
-                            <a:srgbClr val="14213D"/>
-                          </a:solidFill>
-                          <a:latin typeface="Arial"/>
-                        </a:rPr>
                         <a:t>55</a:t>
+                      </a:r>
+                    </a:p>
+                  </a:txBody>
+                  <a:tcPr marL="73152" marR="73152" marT="27432" marB="27432" anchor="ctr">
+                    <a:solidFill>
+                      <a:srgbClr val="FFFFFF"/>
+                    </a:solidFill>
+                  </a:tcPr>
+                </a:tc>
+                <a:tc>
+                  <a:txBody>
+                    <a:bodyPr wrap="square"/>
+                    <a:lstStyle/>
+                    <a:p>
+                      <a:pPr algn="r"/>
+                      <a:r>
+                        <a:rPr sz="1100" b="0">
+                          <a:solidFill>
+                            <a:srgbClr val="14213D"/>
+                          </a:solidFill>
+                          <a:latin typeface="Arial"/>
+                        </a:rPr>
+                        <a:t>4</a:t>
                       </a:r>
                     </a:p>
                   </a:txBody>
@@ -5086,7 +5086,7 @@
                           </a:solidFill>
                           <a:latin typeface="Arial"/>
                         </a:rPr>
-                        <a:t>2</a:t>
+                        <a:t>1</a:t>
                       </a:r>
                     </a:p>
                   </a:txBody>
@@ -5272,30 +5272,30 @@
                           </a:solidFill>
                           <a:latin typeface="Arial"/>
                         </a:rPr>
-                        <a:t>18</a:t>
-                      </a:r>
-                    </a:p>
-                  </a:txBody>
-                  <a:tcPr marL="73152" marR="73152" marT="27432" marB="27432" anchor="ctr">
-                    <a:solidFill>
-                      <a:srgbClr val="FFFFFF"/>
-                    </a:solidFill>
-                  </a:tcPr>
-                </a:tc>
-                <a:tc>
-                  <a:txBody>
-                    <a:bodyPr wrap="square"/>
-                    <a:lstStyle/>
-                    <a:p>
-                      <a:pPr algn="r"/>
-                      <a:r>
-                        <a:rPr sz="1100" b="0">
-                          <a:solidFill>
-                            <a:srgbClr val="14213D"/>
-                          </a:solidFill>
-                          <a:latin typeface="Arial"/>
-                        </a:rPr>
                         <a:t>14</a:t>
+                      </a:r>
+                    </a:p>
+                  </a:txBody>
+                  <a:tcPr marL="73152" marR="73152" marT="27432" marB="27432" anchor="ctr">
+                    <a:solidFill>
+                      <a:srgbClr val="FFFFFF"/>
+                    </a:solidFill>
+                  </a:tcPr>
+                </a:tc>
+                <a:tc>
+                  <a:txBody>
+                    <a:bodyPr wrap="square"/>
+                    <a:lstStyle/>
+                    <a:p>
+                      <a:pPr algn="r"/>
+                      <a:r>
+                        <a:rPr sz="1100" b="0">
+                          <a:solidFill>
+                            <a:srgbClr val="14213D"/>
+                          </a:solidFill>
+                          <a:latin typeface="Arial"/>
+                        </a:rPr>
+                        <a:t>5</a:t>
                       </a:r>
                     </a:p>
                   </a:txBody>
@@ -5458,30 +5458,30 @@
                           </a:solidFill>
                           <a:latin typeface="Arial"/>
                         </a:rPr>
-                        <a:t>12</a:t>
-                      </a:r>
-                    </a:p>
-                  </a:txBody>
-                  <a:tcPr marL="73152" marR="73152" marT="27432" marB="27432" anchor="ctr">
-                    <a:solidFill>
-                      <a:srgbClr val="F7F6F2"/>
-                    </a:solidFill>
-                  </a:tcPr>
-                </a:tc>
-                <a:tc>
-                  <a:txBody>
-                    <a:bodyPr wrap="square"/>
-                    <a:lstStyle/>
-                    <a:p>
-                      <a:pPr algn="r"/>
-                      <a:r>
-                        <a:rPr sz="1100" b="0">
-                          <a:solidFill>
-                            <a:srgbClr val="14213D"/>
-                          </a:solidFill>
-                          <a:latin typeface="Arial"/>
-                        </a:rPr>
                         <a:t>10</a:t>
+                      </a:r>
+                    </a:p>
+                  </a:txBody>
+                  <a:tcPr marL="73152" marR="73152" marT="27432" marB="27432" anchor="ctr">
+                    <a:solidFill>
+                      <a:srgbClr val="F7F6F2"/>
+                    </a:solidFill>
+                  </a:tcPr>
+                </a:tc>
+                <a:tc>
+                  <a:txBody>
+                    <a:bodyPr wrap="square"/>
+                    <a:lstStyle/>
+                    <a:p>
+                      <a:pPr algn="r"/>
+                      <a:r>
+                        <a:rPr sz="1100" b="0">
+                          <a:solidFill>
+                            <a:srgbClr val="14213D"/>
+                          </a:solidFill>
+                          <a:latin typeface="Arial"/>
+                        </a:rPr>
+                        <a:t>2</a:t>
                       </a:r>
                     </a:p>
                   </a:txBody>
@@ -5644,30 +5644,30 @@
                           </a:solidFill>
                           <a:latin typeface="Arial"/>
                         </a:rPr>
-                        <a:t>11</a:t>
-                      </a:r>
-                    </a:p>
-                  </a:txBody>
-                  <a:tcPr marL="73152" marR="73152" marT="27432" marB="27432" anchor="ctr">
-                    <a:solidFill>
-                      <a:srgbClr val="FFFFFF"/>
-                    </a:solidFill>
-                  </a:tcPr>
-                </a:tc>
-                <a:tc>
-                  <a:txBody>
-                    <a:bodyPr wrap="square"/>
-                    <a:lstStyle/>
-                    <a:p>
-                      <a:pPr algn="r"/>
-                      <a:r>
-                        <a:rPr sz="1100" b="0">
-                          <a:solidFill>
-                            <a:srgbClr val="14213D"/>
-                          </a:solidFill>
-                          <a:latin typeface="Arial"/>
-                        </a:rPr>
                         <a:t>7</a:t>
+                      </a:r>
+                    </a:p>
+                  </a:txBody>
+                  <a:tcPr marL="73152" marR="73152" marT="27432" marB="27432" anchor="ctr">
+                    <a:solidFill>
+                      <a:srgbClr val="FFFFFF"/>
+                    </a:solidFill>
+                  </a:tcPr>
+                </a:tc>
+                <a:tc>
+                  <a:txBody>
+                    <a:bodyPr wrap="square"/>
+                    <a:lstStyle/>
+                    <a:p>
+                      <a:pPr algn="r"/>
+                      <a:r>
+                        <a:rPr sz="1100" b="0">
+                          <a:solidFill>
+                            <a:srgbClr val="14213D"/>
+                          </a:solidFill>
+                          <a:latin typeface="Arial"/>
+                        </a:rPr>
+                        <a:t>1</a:t>
                       </a:r>
                     </a:p>
                   </a:txBody>
@@ -5830,30 +5830,30 @@
                           </a:solidFill>
                           <a:latin typeface="Arial"/>
                         </a:rPr>
-                        <a:t>32</a:t>
-                      </a:r>
-                    </a:p>
-                  </a:txBody>
-                  <a:tcPr marL="73152" marR="73152" marT="27432" marB="27432" anchor="ctr">
-                    <a:solidFill>
-                      <a:srgbClr val="F7F6F2"/>
-                    </a:solidFill>
-                  </a:tcPr>
-                </a:tc>
-                <a:tc>
-                  <a:txBody>
-                    <a:bodyPr wrap="square"/>
-                    <a:lstStyle/>
-                    <a:p>
-                      <a:pPr algn="r"/>
-                      <a:r>
-                        <a:rPr sz="1100" b="0">
-                          <a:solidFill>
-                            <a:srgbClr val="14213D"/>
-                          </a:solidFill>
-                          <a:latin typeface="Arial"/>
-                        </a:rPr>
                         <a:t>18</a:t>
+                      </a:r>
+                    </a:p>
+                  </a:txBody>
+                  <a:tcPr marL="73152" marR="73152" marT="27432" marB="27432" anchor="ctr">
+                    <a:solidFill>
+                      <a:srgbClr val="F7F6F2"/>
+                    </a:solidFill>
+                  </a:tcPr>
+                </a:tc>
+                <a:tc>
+                  <a:txBody>
+                    <a:bodyPr wrap="square"/>
+                    <a:lstStyle/>
+                    <a:p>
+                      <a:pPr algn="r"/>
+                      <a:r>
+                        <a:rPr sz="1100" b="0">
+                          <a:solidFill>
+                            <a:srgbClr val="14213D"/>
+                          </a:solidFill>
+                          <a:latin typeface="Arial"/>
+                        </a:rPr>
+                        <a:t>2</a:t>
                       </a:r>
                     </a:p>
                   </a:txBody>
@@ -6016,30 +6016,30 @@
                           </a:solidFill>
                           <a:latin typeface="Arial"/>
                         </a:rPr>
-                        <a:t>173</a:t>
-                      </a:r>
-                    </a:p>
-                  </a:txBody>
-                  <a:tcPr marL="73152" marR="73152" marT="27432" marB="27432" anchor="ctr">
-                    <a:solidFill>
-                      <a:srgbClr val="FFFFFF"/>
-                    </a:solidFill>
-                  </a:tcPr>
-                </a:tc>
-                <a:tc>
-                  <a:txBody>
-                    <a:bodyPr wrap="square"/>
-                    <a:lstStyle/>
-                    <a:p>
-                      <a:pPr algn="r"/>
-                      <a:r>
-                        <a:rPr sz="1100" b="0">
-                          <a:solidFill>
-                            <a:srgbClr val="14213D"/>
-                          </a:solidFill>
-                          <a:latin typeface="Arial"/>
-                        </a:rPr>
                         <a:t>151</a:t>
+                      </a:r>
+                    </a:p>
+                  </a:txBody>
+                  <a:tcPr marL="73152" marR="73152" marT="27432" marB="27432" anchor="ctr">
+                    <a:solidFill>
+                      <a:srgbClr val="FFFFFF"/>
+                    </a:solidFill>
+                  </a:tcPr>
+                </a:tc>
+                <a:tc>
+                  <a:txBody>
+                    <a:bodyPr wrap="square"/>
+                    <a:lstStyle/>
+                    <a:p>
+                      <a:pPr algn="r"/>
+                      <a:r>
+                        <a:rPr sz="1100" b="0">
+                          <a:solidFill>
+                            <a:srgbClr val="14213D"/>
+                          </a:solidFill>
+                          <a:latin typeface="Arial"/>
+                        </a:rPr>
+                        <a:t>0</a:t>
                       </a:r>
                     </a:p>
                   </a:txBody>
@@ -6202,30 +6202,30 @@
                           </a:solidFill>
                           <a:latin typeface="Arial"/>
                         </a:rPr>
-                        <a:t>24</a:t>
-                      </a:r>
-                    </a:p>
-                  </a:txBody>
-                  <a:tcPr marL="73152" marR="73152" marT="27432" marB="27432" anchor="ctr">
-                    <a:solidFill>
-                      <a:srgbClr val="F7F6F2"/>
-                    </a:solidFill>
-                  </a:tcPr>
-                </a:tc>
-                <a:tc>
-                  <a:txBody>
-                    <a:bodyPr wrap="square"/>
-                    <a:lstStyle/>
-                    <a:p>
-                      <a:pPr algn="r"/>
-                      <a:r>
-                        <a:rPr sz="1100" b="0">
-                          <a:solidFill>
-                            <a:srgbClr val="14213D"/>
-                          </a:solidFill>
-                          <a:latin typeface="Arial"/>
-                        </a:rPr>
                         <a:t>23</a:t>
+                      </a:r>
+                    </a:p>
+                  </a:txBody>
+                  <a:tcPr marL="73152" marR="73152" marT="27432" marB="27432" anchor="ctr">
+                    <a:solidFill>
+                      <a:srgbClr val="F7F6F2"/>
+                    </a:solidFill>
+                  </a:tcPr>
+                </a:tc>
+                <a:tc>
+                  <a:txBody>
+                    <a:bodyPr wrap="square"/>
+                    <a:lstStyle/>
+                    <a:p>
+                      <a:pPr algn="r"/>
+                      <a:r>
+                        <a:rPr sz="1100" b="0">
+                          <a:solidFill>
+                            <a:srgbClr val="14213D"/>
+                          </a:solidFill>
+                          <a:latin typeface="Arial"/>
+                        </a:rPr>
+                        <a:t>2</a:t>
                       </a:r>
                     </a:p>
                   </a:txBody>
@@ -6388,30 +6388,30 @@
                           </a:solidFill>
                           <a:latin typeface="Arial"/>
                         </a:rPr>
-                        <a:t>14</a:t>
-                      </a:r>
-                    </a:p>
-                  </a:txBody>
-                  <a:tcPr marL="73152" marR="73152" marT="27432" marB="27432" anchor="ctr">
-                    <a:solidFill>
-                      <a:srgbClr val="FFFFFF"/>
-                    </a:solidFill>
-                  </a:tcPr>
-                </a:tc>
-                <a:tc>
-                  <a:txBody>
-                    <a:bodyPr wrap="square"/>
-                    <a:lstStyle/>
-                    <a:p>
-                      <a:pPr algn="r"/>
-                      <a:r>
-                        <a:rPr sz="1100" b="0">
-                          <a:solidFill>
-                            <a:srgbClr val="14213D"/>
-                          </a:solidFill>
-                          <a:latin typeface="Arial"/>
-                        </a:rPr>
                         <a:t>10</a:t>
+                      </a:r>
+                    </a:p>
+                  </a:txBody>
+                  <a:tcPr marL="73152" marR="73152" marT="27432" marB="27432" anchor="ctr">
+                    <a:solidFill>
+                      <a:srgbClr val="FFFFFF"/>
+                    </a:solidFill>
+                  </a:tcPr>
+                </a:tc>
+                <a:tc>
+                  <a:txBody>
+                    <a:bodyPr wrap="square"/>
+                    <a:lstStyle/>
+                    <a:p>
+                      <a:pPr algn="r"/>
+                      <a:r>
+                        <a:rPr sz="1100" b="0">
+                          <a:solidFill>
+                            <a:srgbClr val="14213D"/>
+                          </a:solidFill>
+                          <a:latin typeface="Arial"/>
+                        </a:rPr>
+                        <a:t>1</a:t>
                       </a:r>
                     </a:p>
                   </a:txBody>
@@ -6574,30 +6574,30 @@
                           </a:solidFill>
                           <a:latin typeface="Arial"/>
                         </a:rPr>
-                        <a:t>12</a:t>
-                      </a:r>
-                    </a:p>
-                  </a:txBody>
-                  <a:tcPr marL="73152" marR="73152" marT="27432" marB="27432" anchor="ctr">
-                    <a:solidFill>
-                      <a:srgbClr val="F7F6F2"/>
-                    </a:solidFill>
-                  </a:tcPr>
-                </a:tc>
-                <a:tc>
-                  <a:txBody>
-                    <a:bodyPr wrap="square"/>
-                    <a:lstStyle/>
-                    <a:p>
-                      <a:pPr algn="r"/>
-                      <a:r>
-                        <a:rPr sz="1100" b="0">
-                          <a:solidFill>
-                            <a:srgbClr val="14213D"/>
-                          </a:solidFill>
-                          <a:latin typeface="Arial"/>
-                        </a:rPr>
                         <a:t>9</a:t>
+                      </a:r>
+                    </a:p>
+                  </a:txBody>
+                  <a:tcPr marL="73152" marR="73152" marT="27432" marB="27432" anchor="ctr">
+                    <a:solidFill>
+                      <a:srgbClr val="F7F6F2"/>
+                    </a:solidFill>
+                  </a:tcPr>
+                </a:tc>
+                <a:tc>
+                  <a:txBody>
+                    <a:bodyPr wrap="square"/>
+                    <a:lstStyle/>
+                    <a:p>
+                      <a:pPr algn="r"/>
+                      <a:r>
+                        <a:rPr sz="1100" b="0">
+                          <a:solidFill>
+                            <a:srgbClr val="14213D"/>
+                          </a:solidFill>
+                          <a:latin typeface="Arial"/>
+                        </a:rPr>
+                        <a:t>4</a:t>
                       </a:r>
                     </a:p>
                   </a:txBody>
@@ -6760,30 +6760,30 @@
                           </a:solidFill>
                           <a:latin typeface="Arial"/>
                         </a:rPr>
-                        <a:t>10</a:t>
-                      </a:r>
-                    </a:p>
-                  </a:txBody>
-                  <a:tcPr marL="73152" marR="73152" marT="27432" marB="27432" anchor="ctr">
-                    <a:solidFill>
-                      <a:srgbClr val="FFFFFF"/>
-                    </a:solidFill>
-                  </a:tcPr>
-                </a:tc>
-                <a:tc>
-                  <a:txBody>
-                    <a:bodyPr wrap="square"/>
-                    <a:lstStyle/>
-                    <a:p>
-                      <a:pPr algn="r"/>
-                      <a:r>
-                        <a:rPr sz="1100" b="0">
-                          <a:solidFill>
-                            <a:srgbClr val="14213D"/>
-                          </a:solidFill>
-                          <a:latin typeface="Arial"/>
-                        </a:rPr>
                         <a:t>8</a:t>
+                      </a:r>
+                    </a:p>
+                  </a:txBody>
+                  <a:tcPr marL="73152" marR="73152" marT="27432" marB="27432" anchor="ctr">
+                    <a:solidFill>
+                      <a:srgbClr val="FFFFFF"/>
+                    </a:solidFill>
+                  </a:tcPr>
+                </a:tc>
+                <a:tc>
+                  <a:txBody>
+                    <a:bodyPr wrap="square"/>
+                    <a:lstStyle/>
+                    <a:p>
+                      <a:pPr algn="r"/>
+                      <a:r>
+                        <a:rPr sz="1100" b="0">
+                          <a:solidFill>
+                            <a:srgbClr val="14213D"/>
+                          </a:solidFill>
+                          <a:latin typeface="Arial"/>
+                        </a:rPr>
+                        <a:t>0</a:t>
                       </a:r>
                     </a:p>
                   </a:txBody>
@@ -6969,7 +6969,7 @@
                           </a:solidFill>
                           <a:latin typeface="Arial"/>
                         </a:rPr>
-                        <a:t>5</a:t>
+                        <a:t>0</a:t>
                       </a:r>
                     </a:p>
                   </a:txBody>
@@ -7155,7 +7155,7 @@
                           </a:solidFill>
                           <a:latin typeface="Arial"/>
                         </a:rPr>
-                        <a:t>5</a:t>
+                        <a:t>0</a:t>
                       </a:r>
                     </a:p>
                   </a:txBody>
@@ -7341,7 +7341,7 @@
                           </a:solidFill>
                           <a:latin typeface="Arial"/>
                         </a:rPr>
-                        <a:t>5</a:t>
+                        <a:t>0</a:t>
                       </a:r>
                     </a:p>
                   </a:txBody>
@@ -7667,7 +7667,7 @@
                           </a:solidFill>
                           <a:latin typeface="Arial"/>
                         </a:rPr>
-                        <a:t>Conv.</a:t>
+                        <a:t>Leads</a:t>
                       </a:r>
                     </a:p>
                   </a:txBody>
@@ -7690,7 +7690,7 @@
                           </a:solidFill>
                           <a:latin typeface="Arial"/>
                         </a:rPr>
-                        <a:t>Leads</a:t>
+                        <a:t>Booked</a:t>
                       </a:r>
                     </a:p>
                   </a:txBody>
@@ -7876,7 +7876,7 @@
                           </a:solidFill>
                           <a:latin typeface="Arial"/>
                         </a:rPr>
-                        <a:t>5</a:t>
+                        <a:t>0</a:t>
                       </a:r>
                     </a:p>
                   </a:txBody>
@@ -8039,30 +8039,30 @@
                           </a:solidFill>
                           <a:latin typeface="Arial"/>
                         </a:rPr>
-                        <a:t>8</a:t>
-                      </a:r>
-                    </a:p>
-                  </a:txBody>
-                  <a:tcPr marL="73152" marR="73152" marT="27432" marB="27432" anchor="ctr">
-                    <a:solidFill>
-                      <a:srgbClr val="F7F6F2"/>
-                    </a:solidFill>
-                  </a:tcPr>
-                </a:tc>
-                <a:tc>
-                  <a:txBody>
-                    <a:bodyPr wrap="square"/>
-                    <a:lstStyle/>
-                    <a:p>
-                      <a:pPr algn="r"/>
-                      <a:r>
-                        <a:rPr sz="1100" b="0">
-                          <a:solidFill>
-                            <a:srgbClr val="14213D"/>
-                          </a:solidFill>
-                          <a:latin typeface="Arial"/>
-                        </a:rPr>
                         <a:t>4</a:t>
+                      </a:r>
+                    </a:p>
+                  </a:txBody>
+                  <a:tcPr marL="73152" marR="73152" marT="27432" marB="27432" anchor="ctr">
+                    <a:solidFill>
+                      <a:srgbClr val="F7F6F2"/>
+                    </a:solidFill>
+                  </a:tcPr>
+                </a:tc>
+                <a:tc>
+                  <a:txBody>
+                    <a:bodyPr wrap="square"/>
+                    <a:lstStyle/>
+                    <a:p>
+                      <a:pPr algn="r"/>
+                      <a:r>
+                        <a:rPr sz="1100" b="0">
+                          <a:solidFill>
+                            <a:srgbClr val="14213D"/>
+                          </a:solidFill>
+                          <a:latin typeface="Arial"/>
+                        </a:rPr>
+                        <a:t>0</a:t>
                       </a:r>
                     </a:p>
                   </a:txBody>
@@ -8248,7 +8248,7 @@
                           </a:solidFill>
                           <a:latin typeface="Arial"/>
                         </a:rPr>
-                        <a:t>4</a:t>
+                        <a:t>1</a:t>
                       </a:r>
                     </a:p>
                   </a:txBody>
@@ -8411,30 +8411,30 @@
                           </a:solidFill>
                           <a:latin typeface="Arial"/>
                         </a:rPr>
-                        <a:t>4</a:t>
-                      </a:r>
-                    </a:p>
-                  </a:txBody>
-                  <a:tcPr marL="73152" marR="73152" marT="27432" marB="27432" anchor="ctr">
-                    <a:solidFill>
-                      <a:srgbClr val="F7F6F2"/>
-                    </a:solidFill>
-                  </a:tcPr>
-                </a:tc>
-                <a:tc>
-                  <a:txBody>
-                    <a:bodyPr wrap="square"/>
-                    <a:lstStyle/>
-                    <a:p>
-                      <a:pPr algn="r"/>
-                      <a:r>
-                        <a:rPr sz="1100" b="0">
-                          <a:solidFill>
-                            <a:srgbClr val="14213D"/>
-                          </a:solidFill>
-                          <a:latin typeface="Arial"/>
-                        </a:rPr>
                         <a:t>3</a:t>
+                      </a:r>
+                    </a:p>
+                  </a:txBody>
+                  <a:tcPr marL="73152" marR="73152" marT="27432" marB="27432" anchor="ctr">
+                    <a:solidFill>
+                      <a:srgbClr val="F7F6F2"/>
+                    </a:solidFill>
+                  </a:tcPr>
+                </a:tc>
+                <a:tc>
+                  <a:txBody>
+                    <a:bodyPr wrap="square"/>
+                    <a:lstStyle/>
+                    <a:p>
+                      <a:pPr algn="r"/>
+                      <a:r>
+                        <a:rPr sz="1100" b="0">
+                          <a:solidFill>
+                            <a:srgbClr val="14213D"/>
+                          </a:solidFill>
+                          <a:latin typeface="Arial"/>
+                        </a:rPr>
+                        <a:t>0</a:t>
                       </a:r>
                     </a:p>
                   </a:txBody>
@@ -8620,7 +8620,7 @@
                           </a:solidFill>
                           <a:latin typeface="Arial"/>
                         </a:rPr>
-                        <a:t>3</a:t>
+                        <a:t>0</a:t>
                       </a:r>
                     </a:p>
                   </a:txBody>
@@ -8783,30 +8783,30 @@
                           </a:solidFill>
                           <a:latin typeface="Arial"/>
                         </a:rPr>
-                        <a:t>4</a:t>
-                      </a:r>
-                    </a:p>
-                  </a:txBody>
-                  <a:tcPr marL="73152" marR="73152" marT="27432" marB="27432" anchor="ctr">
-                    <a:solidFill>
-                      <a:srgbClr val="F7F6F2"/>
-                    </a:solidFill>
-                  </a:tcPr>
-                </a:tc>
-                <a:tc>
-                  <a:txBody>
-                    <a:bodyPr wrap="square"/>
-                    <a:lstStyle/>
-                    <a:p>
-                      <a:pPr algn="r"/>
-                      <a:r>
-                        <a:rPr sz="1100" b="0">
-                          <a:solidFill>
-                            <a:srgbClr val="14213D"/>
-                          </a:solidFill>
-                          <a:latin typeface="Arial"/>
-                        </a:rPr>
                         <a:t>3</a:t>
+                      </a:r>
+                    </a:p>
+                  </a:txBody>
+                  <a:tcPr marL="73152" marR="73152" marT="27432" marB="27432" anchor="ctr">
+                    <a:solidFill>
+                      <a:srgbClr val="F7F6F2"/>
+                    </a:solidFill>
+                  </a:tcPr>
+                </a:tc>
+                <a:tc>
+                  <a:txBody>
+                    <a:bodyPr wrap="square"/>
+                    <a:lstStyle/>
+                    <a:p>
+                      <a:pPr algn="r"/>
+                      <a:r>
+                        <a:rPr sz="1100" b="0">
+                          <a:solidFill>
+                            <a:srgbClr val="14213D"/>
+                          </a:solidFill>
+                          <a:latin typeface="Arial"/>
+                        </a:rPr>
+                        <a:t>1</a:t>
                       </a:r>
                     </a:p>
                   </a:txBody>
@@ -8969,30 +8969,30 @@
                           </a:solidFill>
                           <a:latin typeface="Arial"/>
                         </a:rPr>
-                        <a:t>4</a:t>
-                      </a:r>
-                    </a:p>
-                  </a:txBody>
-                  <a:tcPr marL="73152" marR="73152" marT="27432" marB="27432" anchor="ctr">
-                    <a:solidFill>
-                      <a:srgbClr val="FFFFFF"/>
-                    </a:solidFill>
-                  </a:tcPr>
-                </a:tc>
-                <a:tc>
-                  <a:txBody>
-                    <a:bodyPr wrap="square"/>
-                    <a:lstStyle/>
-                    <a:p>
-                      <a:pPr algn="r"/>
-                      <a:r>
-                        <a:rPr sz="1100" b="0">
-                          <a:solidFill>
-                            <a:srgbClr val="14213D"/>
-                          </a:solidFill>
-                          <a:latin typeface="Arial"/>
-                        </a:rPr>
                         <a:t>3</a:t>
+                      </a:r>
+                    </a:p>
+                  </a:txBody>
+                  <a:tcPr marL="73152" marR="73152" marT="27432" marB="27432" anchor="ctr">
+                    <a:solidFill>
+                      <a:srgbClr val="FFFFFF"/>
+                    </a:solidFill>
+                  </a:tcPr>
+                </a:tc>
+                <a:tc>
+                  <a:txBody>
+                    <a:bodyPr wrap="square"/>
+                    <a:lstStyle/>
+                    <a:p>
+                      <a:pPr algn="r"/>
+                      <a:r>
+                        <a:rPr sz="1100" b="0">
+                          <a:solidFill>
+                            <a:srgbClr val="14213D"/>
+                          </a:solidFill>
+                          <a:latin typeface="Arial"/>
+                        </a:rPr>
+                        <a:t>0</a:t>
                       </a:r>
                     </a:p>
                   </a:txBody>
@@ -9155,30 +9155,30 @@
                           </a:solidFill>
                           <a:latin typeface="Arial"/>
                         </a:rPr>
-                        <a:t>3</a:t>
-                      </a:r>
-                    </a:p>
-                  </a:txBody>
-                  <a:tcPr marL="73152" marR="73152" marT="27432" marB="27432" anchor="ctr">
-                    <a:solidFill>
-                      <a:srgbClr val="F7F6F2"/>
-                    </a:solidFill>
-                  </a:tcPr>
-                </a:tc>
-                <a:tc>
-                  <a:txBody>
-                    <a:bodyPr wrap="square"/>
-                    <a:lstStyle/>
-                    <a:p>
-                      <a:pPr algn="r"/>
-                      <a:r>
-                        <a:rPr sz="1100" b="0">
-                          <a:solidFill>
-                            <a:srgbClr val="14213D"/>
-                          </a:solidFill>
-                          <a:latin typeface="Arial"/>
-                        </a:rPr>
                         <a:t>2</a:t>
+                      </a:r>
+                    </a:p>
+                  </a:txBody>
+                  <a:tcPr marL="73152" marR="73152" marT="27432" marB="27432" anchor="ctr">
+                    <a:solidFill>
+                      <a:srgbClr val="F7F6F2"/>
+                    </a:solidFill>
+                  </a:tcPr>
+                </a:tc>
+                <a:tc>
+                  <a:txBody>
+                    <a:bodyPr wrap="square"/>
+                    <a:lstStyle/>
+                    <a:p>
+                      <a:pPr algn="r"/>
+                      <a:r>
+                        <a:rPr sz="1100" b="0">
+                          <a:solidFill>
+                            <a:srgbClr val="14213D"/>
+                          </a:solidFill>
+                          <a:latin typeface="Arial"/>
+                        </a:rPr>
+                        <a:t>0</a:t>
                       </a:r>
                     </a:p>
                   </a:txBody>
@@ -9364,7 +9364,7 @@
                           </a:solidFill>
                           <a:latin typeface="Arial"/>
                         </a:rPr>
-                        <a:t>2</a:t>
+                        <a:t>0</a:t>
                       </a:r>
                     </a:p>
                   </a:txBody>
@@ -9550,7 +9550,7 @@
                           </a:solidFill>
                           <a:latin typeface="Arial"/>
                         </a:rPr>
-                        <a:t>1</a:t>
+                        <a:t>0</a:t>
                       </a:r>
                     </a:p>
                   </a:txBody>
@@ -9713,30 +9713,30 @@
                           </a:solidFill>
                           <a:latin typeface="Arial"/>
                         </a:rPr>
+                        <a:t>1</a:t>
+                      </a:r>
+                    </a:p>
+                  </a:txBody>
+                  <a:tcPr marL="73152" marR="73152" marT="27432" marB="27432" anchor="ctr">
+                    <a:solidFill>
+                      <a:srgbClr val="FFFFFF"/>
+                    </a:solidFill>
+                  </a:tcPr>
+                </a:tc>
+                <a:tc>
+                  <a:txBody>
+                    <a:bodyPr wrap="square"/>
+                    <a:lstStyle/>
+                    <a:p>
+                      <a:pPr algn="r"/>
+                      <a:r>
+                        <a:rPr sz="1100" b="0">
+                          <a:solidFill>
+                            <a:srgbClr val="14213D"/>
+                          </a:solidFill>
+                          <a:latin typeface="Arial"/>
+                        </a:rPr>
                         <a:t>0</a:t>
-                      </a:r>
-                    </a:p>
-                  </a:txBody>
-                  <a:tcPr marL="73152" marR="73152" marT="27432" marB="27432" anchor="ctr">
-                    <a:solidFill>
-                      <a:srgbClr val="FFFFFF"/>
-                    </a:solidFill>
-                  </a:tcPr>
-                </a:tc>
-                <a:tc>
-                  <a:txBody>
-                    <a:bodyPr wrap="square"/>
-                    <a:lstStyle/>
-                    <a:p>
-                      <a:pPr algn="r"/>
-                      <a:r>
-                        <a:rPr sz="1100" b="0">
-                          <a:solidFill>
-                            <a:srgbClr val="14213D"/>
-                          </a:solidFill>
-                          <a:latin typeface="Arial"/>
-                        </a:rPr>
-                        <a:t>1</a:t>
                       </a:r>
                     </a:p>
                   </a:txBody>
@@ -9922,7 +9922,7 @@
                           </a:solidFill>
                           <a:latin typeface="Arial"/>
                         </a:rPr>
-                        <a:t>1</a:t>
+                        <a:t>0</a:t>
                       </a:r>
                     </a:p>
                   </a:txBody>
@@ -10085,30 +10085,30 @@
                           </a:solidFill>
                           <a:latin typeface="Arial"/>
                         </a:rPr>
-                        <a:t>2</a:t>
-                      </a:r>
-                    </a:p>
-                  </a:txBody>
-                  <a:tcPr marL="73152" marR="73152" marT="27432" marB="27432" anchor="ctr">
-                    <a:solidFill>
-                      <a:srgbClr val="FFFFFF"/>
-                    </a:solidFill>
-                  </a:tcPr>
-                </a:tc>
-                <a:tc>
-                  <a:txBody>
-                    <a:bodyPr wrap="square"/>
-                    <a:lstStyle/>
-                    <a:p>
-                      <a:pPr algn="r"/>
-                      <a:r>
-                        <a:rPr sz="1100" b="0">
-                          <a:solidFill>
-                            <a:srgbClr val="14213D"/>
-                          </a:solidFill>
-                          <a:latin typeface="Arial"/>
-                        </a:rPr>
                         <a:t>1</a:t>
+                      </a:r>
+                    </a:p>
+                  </a:txBody>
+                  <a:tcPr marL="73152" marR="73152" marT="27432" marB="27432" anchor="ctr">
+                    <a:solidFill>
+                      <a:srgbClr val="FFFFFF"/>
+                    </a:solidFill>
+                  </a:tcPr>
+                </a:tc>
+                <a:tc>
+                  <a:txBody>
+                    <a:bodyPr wrap="square"/>
+                    <a:lstStyle/>
+                    <a:p>
+                      <a:pPr algn="r"/>
+                      <a:r>
+                        <a:rPr sz="1100" b="0">
+                          <a:solidFill>
+                            <a:srgbClr val="14213D"/>
+                          </a:solidFill>
+                          <a:latin typeface="Arial"/>
+                        </a:rPr>
+                        <a:t>0</a:t>
                       </a:r>
                     </a:p>
                   </a:txBody>
@@ -10271,7 +10271,7 @@
                           </a:solidFill>
                           <a:latin typeface="Arial"/>
                         </a:rPr>
-                        <a:t>1</a:t>
+                        <a:t>0</a:t>
                       </a:r>
                     </a:p>
                   </a:txBody>
@@ -10737,7 +10737,7 @@
                 </a:solidFill>
                 <a:latin typeface="Arial"/>
               </a:rPr>
-              <a:t>Unique leads = Searchlight "Unique Leads". Closed revenue is credited to the customer's first contact this year. ROAS = closed revenue ÷ ad spend. Booked jobs are not in this export.</a:t>
+              <a:t>Unique leads = Searchlight "Unique Leads". Closed revenue is credited to the customer's first contact this year. Booked jobs = Searchlight "Booked Customers". ROAS = closed revenue ÷ ad spend.</a:t>
             </a:r>
           </a:p>
         </p:txBody>
@@ -11321,7 +11321,7 @@
       </p:sp>
       <p:sp>
         <p:nvSpPr>
-          <p:cNvPr id="13" name="Stat Brand-Assisted (Est.)"/>
+          <p:cNvPr id="13" name="Stat Booked Jobs"/>
           <p:cNvSpPr/>
           <p:nvPr/>
         </p:nvSpPr>
@@ -11397,7 +11397,7 @@
                 </a:solidFill>
                 <a:latin typeface="Arial"/>
               </a:rPr>
-              <a:t>BRAND-ASSISTED (EST.)</a:t>
+              <a:t>BOOKED JOBS</a:t>
             </a:r>
           </a:p>
         </p:txBody>
@@ -11432,7 +11432,7 @@
                 </a:solidFill>
                 <a:latin typeface="Arial"/>
               </a:rPr>
-              <a:t>≈ $225K</a:t>
+              <a:t>714</a:t>
             </a:r>
           </a:p>
         </p:txBody>
@@ -11467,7 +11467,7 @@
                 </a:solidFill>
                 <a:latin typeface="Arial"/>
               </a:rPr>
-              <a:t>Marketing-influenced ≈ $1.07M</a:t>
+              <a:t>20% of unique leads</a:t>
             </a:r>
           </a:p>
         </p:txBody>
@@ -11627,7 +11627,7 @@
       </p:sp>
       <p:sp>
         <p:nvSpPr>
-          <p:cNvPr id="21" name="Stat Cost Per Unique Lead"/>
+          <p:cNvPr id="21" name="Stat Cost Per Booked Job"/>
           <p:cNvSpPr/>
           <p:nvPr/>
         </p:nvSpPr>
@@ -11703,7 +11703,7 @@
                 </a:solidFill>
                 <a:latin typeface="Arial"/>
               </a:rPr>
-              <a:t>COST PER UNIQUE LEAD</a:t>
+              <a:t>COST PER BOOKED JOB</a:t>
             </a:r>
           </a:p>
         </p:txBody>
@@ -11738,7 +11738,7 @@
                 </a:solidFill>
                 <a:latin typeface="Arial"/>
               </a:rPr>
-              <a:t>$48</a:t>
+              <a:t>$244</a:t>
             </a:r>
           </a:p>
         </p:txBody>
@@ -11773,7 +11773,7 @@
                 </a:solidFill>
                 <a:latin typeface="Arial"/>
               </a:rPr>
-              <a:t>Ad spend ÷ all unique leads</a:t>
+              <a:t>$48 per unique lead</a:t>
             </a:r>
           </a:p>
         </p:txBody>
@@ -12149,7 +12149,7 @@
                           </a:solidFill>
                           <a:latin typeface="Arial"/>
                         </a:rPr>
-                        <a:t>Calls &amp; forms</a:t>
+                        <a:t>Unique leads</a:t>
                       </a:r>
                     </a:p>
                   </a:txBody>
@@ -12172,7 +12172,7 @@
                           </a:solidFill>
                           <a:latin typeface="Arial"/>
                         </a:rPr>
-                        <a:t>Unique leads</a:t>
+                        <a:t>Booked jobs</a:t>
                       </a:r>
                     </a:p>
                   </a:txBody>
@@ -12312,7 +12312,7 @@
                           </a:solidFill>
                           <a:latin typeface="Arial"/>
                         </a:rPr>
-                        <a:t>1,602</a:t>
+                        <a:t>1,135</a:t>
                       </a:r>
                     </a:p>
                   </a:txBody>
@@ -12335,7 +12335,7 @@
                           </a:solidFill>
                           <a:latin typeface="Arial"/>
                         </a:rPr>
-                        <a:t>1,135</a:t>
+                        <a:t>155</a:t>
                       </a:r>
                     </a:p>
                   </a:txBody>
@@ -12475,7 +12475,7 @@
                           </a:solidFill>
                           <a:latin typeface="Arial"/>
                         </a:rPr>
-                        <a:t>2,299</a:t>
+                        <a:t>1,820</a:t>
                       </a:r>
                     </a:p>
                   </a:txBody>
@@ -12498,7 +12498,7 @@
                           </a:solidFill>
                           <a:latin typeface="Arial"/>
                         </a:rPr>
-                        <a:t>1,820</a:t>
+                        <a:t>474</a:t>
                       </a:r>
                     </a:p>
                   </a:txBody>
@@ -12638,7 +12638,7 @@
                           </a:solidFill>
                           <a:latin typeface="Arial"/>
                         </a:rPr>
-                        <a:t>894</a:t>
+                        <a:t>530</a:t>
                       </a:r>
                     </a:p>
                   </a:txBody>
@@ -12661,7 +12661,7 @@
                           </a:solidFill>
                           <a:latin typeface="Arial"/>
                         </a:rPr>
-                        <a:t>530</a:t>
+                        <a:t>64</a:t>
                       </a:r>
                     </a:p>
                   </a:txBody>
@@ -12801,7 +12801,7 @@
                           </a:solidFill>
                           <a:latin typeface="Arial"/>
                         </a:rPr>
-                        <a:t>192</a:t>
+                        <a:t>111</a:t>
                       </a:r>
                     </a:p>
                   </a:txBody>
@@ -12824,7 +12824,7 @@
                           </a:solidFill>
                           <a:latin typeface="Arial"/>
                         </a:rPr>
-                        <a:t>111</a:t>
+                        <a:t>14</a:t>
                       </a:r>
                     </a:p>
                   </a:txBody>
@@ -12964,7 +12964,7 @@
                           </a:solidFill>
                           <a:latin typeface="Arial"/>
                         </a:rPr>
-                        <a:t>10</a:t>
+                        <a:t>9</a:t>
                       </a:r>
                     </a:p>
                   </a:txBody>
@@ -12987,7 +12987,7 @@
                           </a:solidFill>
                           <a:latin typeface="Arial"/>
                         </a:rPr>
-                        <a:t>9</a:t>
+                        <a:t>5</a:t>
                       </a:r>
                     </a:p>
                   </a:txBody>
@@ -13127,7 +13127,7 @@
                           </a:solidFill>
                           <a:latin typeface="Arial"/>
                         </a:rPr>
-                        <a:t>10</a:t>
+                        <a:t>8</a:t>
                       </a:r>
                     </a:p>
                   </a:txBody>
@@ -13150,7 +13150,7 @@
                           </a:solidFill>
                           <a:latin typeface="Arial"/>
                         </a:rPr>
-                        <a:t>8</a:t>
+                        <a:t>2</a:t>
                       </a:r>
                     </a:p>
                   </a:txBody>
@@ -13290,7 +13290,7 @@
                           </a:solidFill>
                           <a:latin typeface="Arial"/>
                         </a:rPr>
-                        <a:t>5,007</a:t>
+                        <a:t>3,613</a:t>
                       </a:r>
                     </a:p>
                   </a:txBody>
@@ -13313,7 +13313,7 @@
                           </a:solidFill>
                           <a:latin typeface="Arial"/>
                         </a:rPr>
-                        <a:t>3,613</a:t>
+                        <a:t>714</a:t>
                       </a:r>
                     </a:p>
                   </a:txBody>
@@ -14356,7 +14356,7 @@
                 </a:solidFill>
                 <a:latin typeface="Arial"/>
               </a:rPr>
-              <a:t>161 unique leads</a:t>
+              <a:t>161 unique leads · 78 booked jobs</a:t>
             </a:r>
           </a:p>
         </p:txBody>
@@ -14564,7 +14564,7 @@
                 </a:solidFill>
                 <a:latin typeface="Arial"/>
               </a:rPr>
-              <a:t>478 unique leads</a:t>
+              <a:t>478 unique leads · 173 booked jobs</a:t>
             </a:r>
           </a:p>
           <a:p>
@@ -14788,7 +14788,7 @@
                 </a:solidFill>
                 <a:latin typeface="Arial"/>
               </a:rPr>
-              <a:t>326 unique leads</a:t>
+              <a:t>326 unique leads · 56 booked jobs</a:t>
             </a:r>
           </a:p>
         </p:txBody>
@@ -14943,11 +14943,12 @@
                 <a:tableStyleId>{5C22544A-7EE6-4342-B048-85BDC9FD1C3A}</a:tableStyleId>
               </a:tblPr>
               <a:tblGrid>
-                <a:gridCol w="5852160"/>
+                <a:gridCol w="4937760"/>
+                <a:gridCol w="1371600"/>
+                <a:gridCol w="1280160"/>
+                <a:gridCol w="1005840"/>
                 <a:gridCol w="1463040"/>
-                <a:gridCol w="1371600"/>
-                <a:gridCol w="1463040"/>
-                <a:gridCol w="944575"/>
+                <a:gridCol w="1036015"/>
               </a:tblGrid>
               <a:tr h="365760">
                 <a:tc>
@@ -15032,6 +15033,29 @@
                           </a:solidFill>
                           <a:latin typeface="Arial"/>
                         </a:rPr>
+                        <a:t>Booked</a:t>
+                      </a:r>
+                    </a:p>
+                  </a:txBody>
+                  <a:tcPr marL="73152" marR="73152" marT="27432" marB="27432" anchor="ctr">
+                    <a:solidFill>
+                      <a:srgbClr val="14213D"/>
+                    </a:solidFill>
+                  </a:tcPr>
+                </a:tc>
+                <a:tc>
+                  <a:txBody>
+                    <a:bodyPr wrap="square"/>
+                    <a:lstStyle/>
+                    <a:p>
+                      <a:pPr algn="r"/>
+                      <a:r>
+                        <a:rPr sz="1300" b="1">
+                          <a:solidFill>
+                            <a:srgbClr val="FFFFFF"/>
+                          </a:solidFill>
+                          <a:latin typeface="Arial"/>
+                        </a:rPr>
                         <a:t>Closed rev.</a:t>
                       </a:r>
                     </a:p>
@@ -15149,6 +15173,29 @@
                           </a:solidFill>
                           <a:latin typeface="Arial"/>
                         </a:rPr>
+                        <a:t>41</a:t>
+                      </a:r>
+                    </a:p>
+                  </a:txBody>
+                  <a:tcPr marL="73152" marR="73152" marT="27432" marB="27432" anchor="ctr">
+                    <a:solidFill>
+                      <a:srgbClr val="FFFFFF"/>
+                    </a:solidFill>
+                  </a:tcPr>
+                </a:tc>
+                <a:tc>
+                  <a:txBody>
+                    <a:bodyPr wrap="square"/>
+                    <a:lstStyle/>
+                    <a:p>
+                      <a:pPr algn="r"/>
+                      <a:r>
+                        <a:rPr sz="1300" b="0">
+                          <a:solidFill>
+                            <a:srgbClr val="14213D"/>
+                          </a:solidFill>
+                          <a:latin typeface="Arial"/>
+                        </a:rPr>
                         <a:t>$10,476</a:t>
                       </a:r>
                     </a:p>
@@ -15266,6 +15313,29 @@
                           </a:solidFill>
                           <a:latin typeface="Arial"/>
                         </a:rPr>
+                        <a:t>20</a:t>
+                      </a:r>
+                    </a:p>
+                  </a:txBody>
+                  <a:tcPr marL="73152" marR="73152" marT="27432" marB="27432" anchor="ctr">
+                    <a:solidFill>
+                      <a:srgbClr val="F7F6F2"/>
+                    </a:solidFill>
+                  </a:tcPr>
+                </a:tc>
+                <a:tc>
+                  <a:txBody>
+                    <a:bodyPr wrap="square"/>
+                    <a:lstStyle/>
+                    <a:p>
+                      <a:pPr algn="r"/>
+                      <a:r>
+                        <a:rPr sz="1300" b="0">
+                          <a:solidFill>
+                            <a:srgbClr val="14213D"/>
+                          </a:solidFill>
+                          <a:latin typeface="Arial"/>
+                        </a:rPr>
                         <a:t>$8,127</a:t>
                       </a:r>
                     </a:p>
@@ -15383,6 +15453,29 @@
                           </a:solidFill>
                           <a:latin typeface="Arial"/>
                         </a:rPr>
+                        <a:t>8</a:t>
+                      </a:r>
+                    </a:p>
+                  </a:txBody>
+                  <a:tcPr marL="73152" marR="73152" marT="27432" marB="27432" anchor="ctr">
+                    <a:solidFill>
+                      <a:srgbClr val="FFFFFF"/>
+                    </a:solidFill>
+                  </a:tcPr>
+                </a:tc>
+                <a:tc>
+                  <a:txBody>
+                    <a:bodyPr wrap="square"/>
+                    <a:lstStyle/>
+                    <a:p>
+                      <a:pPr algn="r"/>
+                      <a:r>
+                        <a:rPr sz="1300" b="0">
+                          <a:solidFill>
+                            <a:srgbClr val="14213D"/>
+                          </a:solidFill>
+                          <a:latin typeface="Arial"/>
+                        </a:rPr>
                         <a:t>$10,048</a:t>
                       </a:r>
                     </a:p>
@@ -15500,6 +15593,29 @@
                           </a:solidFill>
                           <a:latin typeface="Arial"/>
                         </a:rPr>
+                        <a:t>15</a:t>
+                      </a:r>
+                    </a:p>
+                  </a:txBody>
+                  <a:tcPr marL="73152" marR="73152" marT="27432" marB="27432" anchor="ctr">
+                    <a:solidFill>
+                      <a:srgbClr val="F7F6F2"/>
+                    </a:solidFill>
+                  </a:tcPr>
+                </a:tc>
+                <a:tc>
+                  <a:txBody>
+                    <a:bodyPr wrap="square"/>
+                    <a:lstStyle/>
+                    <a:p>
+                      <a:pPr algn="r"/>
+                      <a:r>
+                        <a:rPr sz="1300" b="0">
+                          <a:solidFill>
+                            <a:srgbClr val="14213D"/>
+                          </a:solidFill>
+                          <a:latin typeface="Arial"/>
+                        </a:rPr>
                         <a:t>$4,833</a:t>
                       </a:r>
                     </a:p>
@@ -15617,6 +15733,29 @@
                           </a:solidFill>
                           <a:latin typeface="Arial"/>
                         </a:rPr>
+                        <a:t>2</a:t>
+                      </a:r>
+                    </a:p>
+                  </a:txBody>
+                  <a:tcPr marL="73152" marR="73152" marT="27432" marB="27432" anchor="ctr">
+                    <a:solidFill>
+                      <a:srgbClr val="FFFFFF"/>
+                    </a:solidFill>
+                  </a:tcPr>
+                </a:tc>
+                <a:tc>
+                  <a:txBody>
+                    <a:bodyPr wrap="square"/>
+                    <a:lstStyle/>
+                    <a:p>
+                      <a:pPr algn="r"/>
+                      <a:r>
+                        <a:rPr sz="1300" b="0">
+                          <a:solidFill>
+                            <a:srgbClr val="14213D"/>
+                          </a:solidFill>
+                          <a:latin typeface="Arial"/>
+                        </a:rPr>
                         <a:t>$0</a:t>
                       </a:r>
                     </a:p>
@@ -15734,6 +15873,29 @@
                           </a:solidFill>
                           <a:latin typeface="Arial"/>
                         </a:rPr>
+                        <a:t>4</a:t>
+                      </a:r>
+                    </a:p>
+                  </a:txBody>
+                  <a:tcPr marL="73152" marR="73152" marT="27432" marB="27432" anchor="ctr">
+                    <a:solidFill>
+                      <a:srgbClr val="F7F6F2"/>
+                    </a:solidFill>
+                  </a:tcPr>
+                </a:tc>
+                <a:tc>
+                  <a:txBody>
+                    <a:bodyPr wrap="square"/>
+                    <a:lstStyle/>
+                    <a:p>
+                      <a:pPr algn="r"/>
+                      <a:r>
+                        <a:rPr sz="1300" b="0">
+                          <a:solidFill>
+                            <a:srgbClr val="14213D"/>
+                          </a:solidFill>
+                          <a:latin typeface="Arial"/>
+                        </a:rPr>
                         <a:t>$1,146</a:t>
                       </a:r>
                     </a:p>
@@ -15851,6 +16013,29 @@
                           </a:solidFill>
                           <a:latin typeface="Arial"/>
                         </a:rPr>
+                        <a:t>1</a:t>
+                      </a:r>
+                    </a:p>
+                  </a:txBody>
+                  <a:tcPr marL="73152" marR="73152" marT="27432" marB="27432" anchor="ctr">
+                    <a:solidFill>
+                      <a:srgbClr val="FFFFFF"/>
+                    </a:solidFill>
+                  </a:tcPr>
+                </a:tc>
+                <a:tc>
+                  <a:txBody>
+                    <a:bodyPr wrap="square"/>
+                    <a:lstStyle/>
+                    <a:p>
+                      <a:pPr algn="r"/>
+                      <a:r>
+                        <a:rPr sz="1300" b="0">
+                          <a:solidFill>
+                            <a:srgbClr val="14213D"/>
+                          </a:solidFill>
+                          <a:latin typeface="Arial"/>
+                        </a:rPr>
                         <a:t>$319</a:t>
                       </a:r>
                     </a:p>
@@ -15968,6 +16153,29 @@
                           </a:solidFill>
                           <a:latin typeface="Arial"/>
                         </a:rPr>
+                        <a:t>0</a:t>
+                      </a:r>
+                    </a:p>
+                  </a:txBody>
+                  <a:tcPr marL="73152" marR="73152" marT="27432" marB="27432" anchor="ctr">
+                    <a:solidFill>
+                      <a:srgbClr val="F7F6F2"/>
+                    </a:solidFill>
+                  </a:tcPr>
+                </a:tc>
+                <a:tc>
+                  <a:txBody>
+                    <a:bodyPr wrap="square"/>
+                    <a:lstStyle/>
+                    <a:p>
+                      <a:pPr algn="r"/>
+                      <a:r>
+                        <a:rPr sz="1300" b="0">
+                          <a:solidFill>
+                            <a:srgbClr val="14213D"/>
+                          </a:solidFill>
+                          <a:latin typeface="Arial"/>
+                        </a:rPr>
                         <a:t>$0</a:t>
                       </a:r>
                     </a:p>
@@ -16085,6 +16293,29 @@
                           </a:solidFill>
                           <a:latin typeface="Arial"/>
                         </a:rPr>
+                        <a:t>0</a:t>
+                      </a:r>
+                    </a:p>
+                  </a:txBody>
+                  <a:tcPr marL="73152" marR="73152" marT="27432" marB="27432" anchor="ctr">
+                    <a:solidFill>
+                      <a:srgbClr val="FFFFFF"/>
+                    </a:solidFill>
+                  </a:tcPr>
+                </a:tc>
+                <a:tc>
+                  <a:txBody>
+                    <a:bodyPr wrap="square"/>
+                    <a:lstStyle/>
+                    <a:p>
+                      <a:pPr algn="r"/>
+                      <a:r>
+                        <a:rPr sz="1300" b="0">
+                          <a:solidFill>
+                            <a:srgbClr val="14213D"/>
+                          </a:solidFill>
+                          <a:latin typeface="Arial"/>
+                        </a:rPr>
                         <a:t>$0</a:t>
                       </a:r>
                     </a:p>
@@ -16202,6 +16433,29 @@
                           </a:solidFill>
                           <a:latin typeface="Arial"/>
                         </a:rPr>
+                        <a:t>0</a:t>
+                      </a:r>
+                    </a:p>
+                  </a:txBody>
+                  <a:tcPr marL="73152" marR="73152" marT="27432" marB="27432" anchor="ctr">
+                    <a:solidFill>
+                      <a:srgbClr val="F7F6F2"/>
+                    </a:solidFill>
+                  </a:tcPr>
+                </a:tc>
+                <a:tc>
+                  <a:txBody>
+                    <a:bodyPr wrap="square"/>
+                    <a:lstStyle/>
+                    <a:p>
+                      <a:pPr algn="r"/>
+                      <a:r>
+                        <a:rPr sz="1300" b="0">
+                          <a:solidFill>
+                            <a:srgbClr val="14213D"/>
+                          </a:solidFill>
+                          <a:latin typeface="Arial"/>
+                        </a:rPr>
                         <a:t>$0</a:t>
                       </a:r>
                     </a:p>
@@ -16297,6 +16551,29 @@
                           <a:latin typeface="Arial"/>
                         </a:rPr>
                         <a:t>422</a:t>
+                      </a:r>
+                    </a:p>
+                  </a:txBody>
+                  <a:tcPr marL="73152" marR="73152" marT="27432" marB="27432" anchor="ctr">
+                    <a:solidFill>
+                      <a:srgbClr val="FBE7D6"/>
+                    </a:solidFill>
+                  </a:tcPr>
+                </a:tc>
+                <a:tc>
+                  <a:txBody>
+                    <a:bodyPr wrap="square"/>
+                    <a:lstStyle/>
+                    <a:p>
+                      <a:pPr algn="r"/>
+                      <a:r>
+                        <a:rPr sz="1300" b="1">
+                          <a:solidFill>
+                            <a:srgbClr val="14213D"/>
+                          </a:solidFill>
+                          <a:latin typeface="Arial"/>
+                        </a:rPr>
+                        <a:t>91</a:t>
                       </a:r>
                     </a:p>
                   </a:txBody>
@@ -16413,7 +16690,7 @@
                 </a:solidFill>
                 <a:latin typeface="Arial"/>
               </a:rPr>
-              <a:t>Unpaid sources: Charleston GBP is the largest revenue source</a:t>
+              <a:t>Charleston GBP brings the most revenue but books only 7% of its leads</a:t>
             </a:r>
           </a:p>
         </p:txBody>
@@ -16574,7 +16851,7 @@
                           </a:solidFill>
                           <a:latin typeface="Arial"/>
                         </a:rPr>
-                        <a:t>Calls &amp; forms</a:t>
+                        <a:t>Unique leads</a:t>
                       </a:r>
                     </a:p>
                   </a:txBody>
@@ -16597,7 +16874,7 @@
                           </a:solidFill>
                           <a:latin typeface="Arial"/>
                         </a:rPr>
-                        <a:t>Unique leads</a:t>
+                        <a:t>Booked jobs</a:t>
                       </a:r>
                     </a:p>
                   </a:txBody>
@@ -16620,30 +16897,30 @@
                           </a:solidFill>
                           <a:latin typeface="Arial"/>
                         </a:rPr>
+                        <a:t>Book rate</a:t>
+                      </a:r>
+                    </a:p>
+                  </a:txBody>
+                  <a:tcPr marL="73152" marR="73152" marT="27432" marB="27432" anchor="ctr">
+                    <a:solidFill>
+                      <a:srgbClr val="14213D"/>
+                    </a:solidFill>
+                  </a:tcPr>
+                </a:tc>
+                <a:tc>
+                  <a:txBody>
+                    <a:bodyPr wrap="square"/>
+                    <a:lstStyle/>
+                    <a:p>
+                      <a:pPr algn="r"/>
+                      <a:r>
+                        <a:rPr sz="1500" b="1">
+                          <a:solidFill>
+                            <a:srgbClr val="FFFFFF"/>
+                          </a:solidFill>
+                          <a:latin typeface="Arial"/>
+                        </a:rPr>
                         <a:t>Closed rev.</a:t>
-                      </a:r>
-                    </a:p>
-                  </a:txBody>
-                  <a:tcPr marL="73152" marR="73152" marT="27432" marB="27432" anchor="ctr">
-                    <a:solidFill>
-                      <a:srgbClr val="14213D"/>
-                    </a:solidFill>
-                  </a:tcPr>
-                </a:tc>
-                <a:tc>
-                  <a:txBody>
-                    <a:bodyPr wrap="square"/>
-                    <a:lstStyle/>
-                    <a:p>
-                      <a:pPr algn="r"/>
-                      <a:r>
-                        <a:rPr sz="1500" b="1">
-                          <a:solidFill>
-                            <a:srgbClr val="FFFFFF"/>
-                          </a:solidFill>
-                          <a:latin typeface="Arial"/>
-                        </a:rPr>
-                        <a:t>Revenue per lead</a:t>
                       </a:r>
                     </a:p>
                   </a:txBody>
@@ -16714,7 +16991,7 @@
                           </a:solidFill>
                           <a:latin typeface="Arial"/>
                         </a:rPr>
-                        <a:t>951</a:t>
+                        <a:t>636</a:t>
                       </a:r>
                     </a:p>
                   </a:txBody>
@@ -16737,7 +17014,7 @@
                           </a:solidFill>
                           <a:latin typeface="Arial"/>
                         </a:rPr>
-                        <a:t>636</a:t>
+                        <a:t>47</a:t>
                       </a:r>
                     </a:p>
                   </a:txBody>
@@ -16760,30 +17037,30 @@
                           </a:solidFill>
                           <a:latin typeface="Arial"/>
                         </a:rPr>
+                        <a:t>7%</a:t>
+                      </a:r>
+                    </a:p>
+                  </a:txBody>
+                  <a:tcPr marL="73152" marR="73152" marT="27432" marB="27432" anchor="ctr">
+                    <a:solidFill>
+                      <a:srgbClr val="FFFFFF"/>
+                    </a:solidFill>
+                  </a:tcPr>
+                </a:tc>
+                <a:tc>
+                  <a:txBody>
+                    <a:bodyPr wrap="square"/>
+                    <a:lstStyle/>
+                    <a:p>
+                      <a:pPr algn="r"/>
+                      <a:r>
+                        <a:rPr sz="1500" b="0">
+                          <a:solidFill>
+                            <a:srgbClr val="14213D"/>
+                          </a:solidFill>
+                          <a:latin typeface="Arial"/>
+                        </a:rPr>
                         <a:t>$213,907</a:t>
-                      </a:r>
-                    </a:p>
-                  </a:txBody>
-                  <a:tcPr marL="73152" marR="73152" marT="27432" marB="27432" anchor="ctr">
-                    <a:solidFill>
-                      <a:srgbClr val="FFFFFF"/>
-                    </a:solidFill>
-                  </a:tcPr>
-                </a:tc>
-                <a:tc>
-                  <a:txBody>
-                    <a:bodyPr wrap="square"/>
-                    <a:lstStyle/>
-                    <a:p>
-                      <a:pPr algn="r"/>
-                      <a:r>
-                        <a:rPr sz="1500" b="0">
-                          <a:solidFill>
-                            <a:srgbClr val="14213D"/>
-                          </a:solidFill>
-                          <a:latin typeface="Arial"/>
-                        </a:rPr>
-                        <a:t>$336</a:t>
                       </a:r>
                     </a:p>
                   </a:txBody>
@@ -16854,7 +17131,7 @@
                           </a:solidFill>
                           <a:latin typeface="Arial"/>
                         </a:rPr>
-                        <a:t>237</a:t>
+                        <a:t>158</a:t>
                       </a:r>
                     </a:p>
                   </a:txBody>
@@ -16877,7 +17154,7 @@
                           </a:solidFill>
                           <a:latin typeface="Arial"/>
                         </a:rPr>
-                        <a:t>158</a:t>
+                        <a:t>44</a:t>
                       </a:r>
                     </a:p>
                   </a:txBody>
@@ -16900,30 +17177,30 @@
                           </a:solidFill>
                           <a:latin typeface="Arial"/>
                         </a:rPr>
+                        <a:t>28%</a:t>
+                      </a:r>
+                    </a:p>
+                  </a:txBody>
+                  <a:tcPr marL="73152" marR="73152" marT="27432" marB="27432" anchor="ctr">
+                    <a:solidFill>
+                      <a:srgbClr val="F7F6F2"/>
+                    </a:solidFill>
+                  </a:tcPr>
+                </a:tc>
+                <a:tc>
+                  <a:txBody>
+                    <a:bodyPr wrap="square"/>
+                    <a:lstStyle/>
+                    <a:p>
+                      <a:pPr algn="r"/>
+                      <a:r>
+                        <a:rPr sz="1500" b="0">
+                          <a:solidFill>
+                            <a:srgbClr val="14213D"/>
+                          </a:solidFill>
+                          <a:latin typeface="Arial"/>
+                        </a:rPr>
                         <a:t>$90,250</a:t>
-                      </a:r>
-                    </a:p>
-                  </a:txBody>
-                  <a:tcPr marL="73152" marR="73152" marT="27432" marB="27432" anchor="ctr">
-                    <a:solidFill>
-                      <a:srgbClr val="F7F6F2"/>
-                    </a:solidFill>
-                  </a:tcPr>
-                </a:tc>
-                <a:tc>
-                  <a:txBody>
-                    <a:bodyPr wrap="square"/>
-                    <a:lstStyle/>
-                    <a:p>
-                      <a:pPr algn="r"/>
-                      <a:r>
-                        <a:rPr sz="1500" b="0">
-                          <a:solidFill>
-                            <a:srgbClr val="14213D"/>
-                          </a:solidFill>
-                          <a:latin typeface="Arial"/>
-                        </a:rPr>
-                        <a:t>$571</a:t>
                       </a:r>
                     </a:p>
                   </a:txBody>
@@ -16994,7 +17271,7 @@
                           </a:solidFill>
                           <a:latin typeface="Arial"/>
                         </a:rPr>
-                        <a:t>60</a:t>
+                        <a:t>54</a:t>
                       </a:r>
                     </a:p>
                   </a:txBody>
@@ -17017,7 +17294,7 @@
                           </a:solidFill>
                           <a:latin typeface="Arial"/>
                         </a:rPr>
-                        <a:t>54</a:t>
+                        <a:t>21</a:t>
                       </a:r>
                     </a:p>
                   </a:txBody>
@@ -17040,30 +17317,30 @@
                           </a:solidFill>
                           <a:latin typeface="Arial"/>
                         </a:rPr>
+                        <a:t>39%</a:t>
+                      </a:r>
+                    </a:p>
+                  </a:txBody>
+                  <a:tcPr marL="73152" marR="73152" marT="27432" marB="27432" anchor="ctr">
+                    <a:solidFill>
+                      <a:srgbClr val="FFFFFF"/>
+                    </a:solidFill>
+                  </a:tcPr>
+                </a:tc>
+                <a:tc>
+                  <a:txBody>
+                    <a:bodyPr wrap="square"/>
+                    <a:lstStyle/>
+                    <a:p>
+                      <a:pPr algn="r"/>
+                      <a:r>
+                        <a:rPr sz="1500" b="0">
+                          <a:solidFill>
+                            <a:srgbClr val="14213D"/>
+                          </a:solidFill>
+                          <a:latin typeface="Arial"/>
+                        </a:rPr>
                         <a:t>$54,291</a:t>
-                      </a:r>
-                    </a:p>
-                  </a:txBody>
-                  <a:tcPr marL="73152" marR="73152" marT="27432" marB="27432" anchor="ctr">
-                    <a:solidFill>
-                      <a:srgbClr val="FFFFFF"/>
-                    </a:solidFill>
-                  </a:tcPr>
-                </a:tc>
-                <a:tc>
-                  <a:txBody>
-                    <a:bodyPr wrap="square"/>
-                    <a:lstStyle/>
-                    <a:p>
-                      <a:pPr algn="r"/>
-                      <a:r>
-                        <a:rPr sz="1500" b="0">
-                          <a:solidFill>
-                            <a:srgbClr val="14213D"/>
-                          </a:solidFill>
-                          <a:latin typeface="Arial"/>
-                        </a:rPr>
-                        <a:t>$1,005</a:t>
                       </a:r>
                     </a:p>
                   </a:txBody>
@@ -17134,7 +17411,7 @@
                           </a:solidFill>
                           <a:latin typeface="Arial"/>
                         </a:rPr>
-                        <a:t>147</a:t>
+                        <a:t>100</a:t>
                       </a:r>
                     </a:p>
                   </a:txBody>
@@ -17157,7 +17434,7 @@
                           </a:solidFill>
                           <a:latin typeface="Arial"/>
                         </a:rPr>
-                        <a:t>100</a:t>
+                        <a:t>31</a:t>
                       </a:r>
                     </a:p>
                   </a:txBody>
@@ -17180,30 +17457,30 @@
                           </a:solidFill>
                           <a:latin typeface="Arial"/>
                         </a:rPr>
+                        <a:t>31%</a:t>
+                      </a:r>
+                    </a:p>
+                  </a:txBody>
+                  <a:tcPr marL="73152" marR="73152" marT="27432" marB="27432" anchor="ctr">
+                    <a:solidFill>
+                      <a:srgbClr val="F7F6F2"/>
+                    </a:solidFill>
+                  </a:tcPr>
+                </a:tc>
+                <a:tc>
+                  <a:txBody>
+                    <a:bodyPr wrap="square"/>
+                    <a:lstStyle/>
+                    <a:p>
+                      <a:pPr algn="r"/>
+                      <a:r>
+                        <a:rPr sz="1500" b="0">
+                          <a:solidFill>
+                            <a:srgbClr val="14213D"/>
+                          </a:solidFill>
+                          <a:latin typeface="Arial"/>
+                        </a:rPr>
                         <a:t>$50,471</a:t>
-                      </a:r>
-                    </a:p>
-                  </a:txBody>
-                  <a:tcPr marL="73152" marR="73152" marT="27432" marB="27432" anchor="ctr">
-                    <a:solidFill>
-                      <a:srgbClr val="F7F6F2"/>
-                    </a:solidFill>
-                  </a:tcPr>
-                </a:tc>
-                <a:tc>
-                  <a:txBody>
-                    <a:bodyPr wrap="square"/>
-                    <a:lstStyle/>
-                    <a:p>
-                      <a:pPr algn="r"/>
-                      <a:r>
-                        <a:rPr sz="1500" b="0">
-                          <a:solidFill>
-                            <a:srgbClr val="14213D"/>
-                          </a:solidFill>
-                          <a:latin typeface="Arial"/>
-                        </a:rPr>
-                        <a:t>$505</a:t>
                       </a:r>
                     </a:p>
                   </a:txBody>
@@ -17274,7 +17551,7 @@
                           </a:solidFill>
                           <a:latin typeface="Arial"/>
                         </a:rPr>
-                        <a:t>302</a:t>
+                        <a:t>245</a:t>
                       </a:r>
                     </a:p>
                   </a:txBody>
@@ -17297,7 +17574,7 @@
                           </a:solidFill>
                           <a:latin typeface="Arial"/>
                         </a:rPr>
-                        <a:t>245</a:t>
+                        <a:t>31</a:t>
                       </a:r>
                     </a:p>
                   </a:txBody>
@@ -17320,30 +17597,30 @@
                           </a:solidFill>
                           <a:latin typeface="Arial"/>
                         </a:rPr>
+                        <a:t>13%</a:t>
+                      </a:r>
+                    </a:p>
+                  </a:txBody>
+                  <a:tcPr marL="73152" marR="73152" marT="27432" marB="27432" anchor="ctr">
+                    <a:solidFill>
+                      <a:srgbClr val="FFFFFF"/>
+                    </a:solidFill>
+                  </a:tcPr>
+                </a:tc>
+                <a:tc>
+                  <a:txBody>
+                    <a:bodyPr wrap="square"/>
+                    <a:lstStyle/>
+                    <a:p>
+                      <a:pPr algn="r"/>
+                      <a:r>
+                        <a:rPr sz="1500" b="0">
+                          <a:solidFill>
+                            <a:srgbClr val="14213D"/>
+                          </a:solidFill>
+                          <a:latin typeface="Arial"/>
+                        </a:rPr>
                         <a:t>$25,849</a:t>
-                      </a:r>
-                    </a:p>
-                  </a:txBody>
-                  <a:tcPr marL="73152" marR="73152" marT="27432" marB="27432" anchor="ctr">
-                    <a:solidFill>
-                      <a:srgbClr val="FFFFFF"/>
-                    </a:solidFill>
-                  </a:tcPr>
-                </a:tc>
-                <a:tc>
-                  <a:txBody>
-                    <a:bodyPr wrap="square"/>
-                    <a:lstStyle/>
-                    <a:p>
-                      <a:pPr algn="r"/>
-                      <a:r>
-                        <a:rPr sz="1500" b="0">
-                          <a:solidFill>
-                            <a:srgbClr val="14213D"/>
-                          </a:solidFill>
-                          <a:latin typeface="Arial"/>
-                        </a:rPr>
-                        <a:t>$106</a:t>
                       </a:r>
                     </a:p>
                   </a:txBody>
@@ -17414,7 +17691,7 @@
                           </a:solidFill>
                           <a:latin typeface="Arial"/>
                         </a:rPr>
-                        <a:t>137</a:t>
+                        <a:t>105</a:t>
                       </a:r>
                     </a:p>
                   </a:txBody>
@@ -17437,7 +17714,7 @@
                           </a:solidFill>
                           <a:latin typeface="Arial"/>
                         </a:rPr>
-                        <a:t>105</a:t>
+                        <a:t>1</a:t>
                       </a:r>
                     </a:p>
                   </a:txBody>
@@ -17460,30 +17737,30 @@
                           </a:solidFill>
                           <a:latin typeface="Arial"/>
                         </a:rPr>
+                        <a:t>1%</a:t>
+                      </a:r>
+                    </a:p>
+                  </a:txBody>
+                  <a:tcPr marL="73152" marR="73152" marT="27432" marB="27432" anchor="ctr">
+                    <a:solidFill>
+                      <a:srgbClr val="F7F6F2"/>
+                    </a:solidFill>
+                  </a:tcPr>
+                </a:tc>
+                <a:tc>
+                  <a:txBody>
+                    <a:bodyPr wrap="square"/>
+                    <a:lstStyle/>
+                    <a:p>
+                      <a:pPr algn="r"/>
+                      <a:r>
+                        <a:rPr sz="1500" b="0">
+                          <a:solidFill>
+                            <a:srgbClr val="14213D"/>
+                          </a:solidFill>
+                          <a:latin typeface="Arial"/>
+                        </a:rPr>
                         <a:t>$18,031</a:t>
-                      </a:r>
-                    </a:p>
-                  </a:txBody>
-                  <a:tcPr marL="73152" marR="73152" marT="27432" marB="27432" anchor="ctr">
-                    <a:solidFill>
-                      <a:srgbClr val="F7F6F2"/>
-                    </a:solidFill>
-                  </a:tcPr>
-                </a:tc>
-                <a:tc>
-                  <a:txBody>
-                    <a:bodyPr wrap="square"/>
-                    <a:lstStyle/>
-                    <a:p>
-                      <a:pPr algn="r"/>
-                      <a:r>
-                        <a:rPr sz="1500" b="0">
-                          <a:solidFill>
-                            <a:srgbClr val="14213D"/>
-                          </a:solidFill>
-                          <a:latin typeface="Arial"/>
-                        </a:rPr>
-                        <a:t>$172</a:t>
                       </a:r>
                     </a:p>
                   </a:txBody>
@@ -17554,7 +17831,7 @@
                           </a:solidFill>
                           <a:latin typeface="Arial"/>
                         </a:rPr>
-                        <a:t>192</a:t>
+                        <a:t>111</a:t>
                       </a:r>
                     </a:p>
                   </a:txBody>
@@ -17577,7 +17854,7 @@
                           </a:solidFill>
                           <a:latin typeface="Arial"/>
                         </a:rPr>
-                        <a:t>111</a:t>
+                        <a:t>14</a:t>
                       </a:r>
                     </a:p>
                   </a:txBody>
@@ -17600,30 +17877,30 @@
                           </a:solidFill>
                           <a:latin typeface="Arial"/>
                         </a:rPr>
+                        <a:t>13%</a:t>
+                      </a:r>
+                    </a:p>
+                  </a:txBody>
+                  <a:tcPr marL="73152" marR="73152" marT="27432" marB="27432" anchor="ctr">
+                    <a:solidFill>
+                      <a:srgbClr val="FFFFFF"/>
+                    </a:solidFill>
+                  </a:tcPr>
+                </a:tc>
+                <a:tc>
+                  <a:txBody>
+                    <a:bodyPr wrap="square"/>
+                    <a:lstStyle/>
+                    <a:p>
+                      <a:pPr algn="r"/>
+                      <a:r>
+                        <a:rPr sz="1500" b="0">
+                          <a:solidFill>
+                            <a:srgbClr val="14213D"/>
+                          </a:solidFill>
+                          <a:latin typeface="Arial"/>
+                        </a:rPr>
                         <a:t>$16,989</a:t>
-                      </a:r>
-                    </a:p>
-                  </a:txBody>
-                  <a:tcPr marL="73152" marR="73152" marT="27432" marB="27432" anchor="ctr">
-                    <a:solidFill>
-                      <a:srgbClr val="FFFFFF"/>
-                    </a:solidFill>
-                  </a:tcPr>
-                </a:tc>
-                <a:tc>
-                  <a:txBody>
-                    <a:bodyPr wrap="square"/>
-                    <a:lstStyle/>
-                    <a:p>
-                      <a:pPr algn="r"/>
-                      <a:r>
-                        <a:rPr sz="1500" b="0">
-                          <a:solidFill>
-                            <a:srgbClr val="14213D"/>
-                          </a:solidFill>
-                          <a:latin typeface="Arial"/>
-                        </a:rPr>
-                        <a:t>$153</a:t>
                       </a:r>
                     </a:p>
                   </a:txBody>
@@ -17694,7 +17971,7 @@
                           </a:solidFill>
                           <a:latin typeface="Arial"/>
                         </a:rPr>
-                        <a:t>230</a:t>
+                        <a:t>194</a:t>
                       </a:r>
                     </a:p>
                   </a:txBody>
@@ -17717,7 +17994,7 @@
                           </a:solidFill>
                           <a:latin typeface="Arial"/>
                         </a:rPr>
-                        <a:t>194</a:t>
+                        <a:t>12</a:t>
                       </a:r>
                     </a:p>
                   </a:txBody>
@@ -17740,30 +18017,30 @@
                           </a:solidFill>
                           <a:latin typeface="Arial"/>
                         </a:rPr>
+                        <a:t>6%</a:t>
+                      </a:r>
+                    </a:p>
+                  </a:txBody>
+                  <a:tcPr marL="73152" marR="73152" marT="27432" marB="27432" anchor="ctr">
+                    <a:solidFill>
+                      <a:srgbClr val="F7F6F2"/>
+                    </a:solidFill>
+                  </a:tcPr>
+                </a:tc>
+                <a:tc>
+                  <a:txBody>
+                    <a:bodyPr wrap="square"/>
+                    <a:lstStyle/>
+                    <a:p>
+                      <a:pPr algn="r"/>
+                      <a:r>
+                        <a:rPr sz="1500" b="0">
+                          <a:solidFill>
+                            <a:srgbClr val="14213D"/>
+                          </a:solidFill>
+                          <a:latin typeface="Arial"/>
+                        </a:rPr>
                         <a:t>$16,930</a:t>
-                      </a:r>
-                    </a:p>
-                  </a:txBody>
-                  <a:tcPr marL="73152" marR="73152" marT="27432" marB="27432" anchor="ctr">
-                    <a:solidFill>
-                      <a:srgbClr val="F7F6F2"/>
-                    </a:solidFill>
-                  </a:tcPr>
-                </a:tc>
-                <a:tc>
-                  <a:txBody>
-                    <a:bodyPr wrap="square"/>
-                    <a:lstStyle/>
-                    <a:p>
-                      <a:pPr algn="r"/>
-                      <a:r>
-                        <a:rPr sz="1500" b="0">
-                          <a:solidFill>
-                            <a:srgbClr val="14213D"/>
-                          </a:solidFill>
-                          <a:latin typeface="Arial"/>
-                        </a:rPr>
-                        <a:t>$87</a:t>
                       </a:r>
                     </a:p>
                   </a:txBody>
@@ -18043,7 +18320,7 @@
                           </a:solidFill>
                           <a:latin typeface="Arial"/>
                         </a:rPr>
-                        <a:t>Conv.</a:t>
+                        <a:t>Leads</a:t>
                       </a:r>
                     </a:p>
                   </a:txBody>
@@ -18066,7 +18343,7 @@
                           </a:solidFill>
                           <a:latin typeface="Arial"/>
                         </a:rPr>
-                        <a:t>Leads</a:t>
+                        <a:t>Booked</a:t>
                       </a:r>
                     </a:p>
                   </a:txBody>
@@ -18229,30 +18506,30 @@
                           </a:solidFill>
                           <a:latin typeface="Arial"/>
                         </a:rPr>
-                        <a:t>951</a:t>
-                      </a:r>
-                    </a:p>
-                  </a:txBody>
-                  <a:tcPr marL="73152" marR="73152" marT="27432" marB="27432" anchor="ctr">
-                    <a:solidFill>
-                      <a:srgbClr val="FFFFFF"/>
-                    </a:solidFill>
-                  </a:tcPr>
-                </a:tc>
-                <a:tc>
-                  <a:txBody>
-                    <a:bodyPr wrap="square"/>
-                    <a:lstStyle/>
-                    <a:p>
-                      <a:pPr algn="r"/>
-                      <a:r>
-                        <a:rPr sz="1100" b="0">
-                          <a:solidFill>
-                            <a:srgbClr val="14213D"/>
-                          </a:solidFill>
-                          <a:latin typeface="Arial"/>
-                        </a:rPr>
                         <a:t>636</a:t>
+                      </a:r>
+                    </a:p>
+                  </a:txBody>
+                  <a:tcPr marL="73152" marR="73152" marT="27432" marB="27432" anchor="ctr">
+                    <a:solidFill>
+                      <a:srgbClr val="FFFFFF"/>
+                    </a:solidFill>
+                  </a:tcPr>
+                </a:tc>
+                <a:tc>
+                  <a:txBody>
+                    <a:bodyPr wrap="square"/>
+                    <a:lstStyle/>
+                    <a:p>
+                      <a:pPr algn="r"/>
+                      <a:r>
+                        <a:rPr sz="1100" b="0">
+                          <a:solidFill>
+                            <a:srgbClr val="14213D"/>
+                          </a:solidFill>
+                          <a:latin typeface="Arial"/>
+                        </a:rPr>
+                        <a:t>47</a:t>
                       </a:r>
                     </a:p>
                   </a:txBody>
@@ -18415,30 +18692,30 @@
                           </a:solidFill>
                           <a:latin typeface="Arial"/>
                         </a:rPr>
-                        <a:t>237</a:t>
-                      </a:r>
-                    </a:p>
-                  </a:txBody>
-                  <a:tcPr marL="73152" marR="73152" marT="27432" marB="27432" anchor="ctr">
-                    <a:solidFill>
-                      <a:srgbClr val="F7F6F2"/>
-                    </a:solidFill>
-                  </a:tcPr>
-                </a:tc>
-                <a:tc>
-                  <a:txBody>
-                    <a:bodyPr wrap="square"/>
-                    <a:lstStyle/>
-                    <a:p>
-                      <a:pPr algn="r"/>
-                      <a:r>
-                        <a:rPr sz="1100" b="0">
-                          <a:solidFill>
-                            <a:srgbClr val="14213D"/>
-                          </a:solidFill>
-                          <a:latin typeface="Arial"/>
-                        </a:rPr>
                         <a:t>158</a:t>
+                      </a:r>
+                    </a:p>
+                  </a:txBody>
+                  <a:tcPr marL="73152" marR="73152" marT="27432" marB="27432" anchor="ctr">
+                    <a:solidFill>
+                      <a:srgbClr val="F7F6F2"/>
+                    </a:solidFill>
+                  </a:tcPr>
+                </a:tc>
+                <a:tc>
+                  <a:txBody>
+                    <a:bodyPr wrap="square"/>
+                    <a:lstStyle/>
+                    <a:p>
+                      <a:pPr algn="r"/>
+                      <a:r>
+                        <a:rPr sz="1100" b="0">
+                          <a:solidFill>
+                            <a:srgbClr val="14213D"/>
+                          </a:solidFill>
+                          <a:latin typeface="Arial"/>
+                        </a:rPr>
+                        <a:t>44</a:t>
                       </a:r>
                     </a:p>
                   </a:txBody>
@@ -18601,30 +18878,30 @@
                           </a:solidFill>
                           <a:latin typeface="Arial"/>
                         </a:rPr>
-                        <a:t>450</a:t>
-                      </a:r>
-                    </a:p>
-                  </a:txBody>
-                  <a:tcPr marL="73152" marR="73152" marT="27432" marB="27432" anchor="ctr">
-                    <a:solidFill>
-                      <a:srgbClr val="FFFFFF"/>
-                    </a:solidFill>
-                  </a:tcPr>
-                </a:tc>
-                <a:tc>
-                  <a:txBody>
-                    <a:bodyPr wrap="square"/>
-                    <a:lstStyle/>
-                    <a:p>
-                      <a:pPr algn="r"/>
-                      <a:r>
-                        <a:rPr sz="1100" b="0">
-                          <a:solidFill>
-                            <a:srgbClr val="14213D"/>
-                          </a:solidFill>
-                          <a:latin typeface="Arial"/>
-                        </a:rPr>
                         <a:t>358</a:t>
+                      </a:r>
+                    </a:p>
+                  </a:txBody>
+                  <a:tcPr marL="73152" marR="73152" marT="27432" marB="27432" anchor="ctr">
+                    <a:solidFill>
+                      <a:srgbClr val="FFFFFF"/>
+                    </a:solidFill>
+                  </a:tcPr>
+                </a:tc>
+                <a:tc>
+                  <a:txBody>
+                    <a:bodyPr wrap="square"/>
+                    <a:lstStyle/>
+                    <a:p>
+                      <a:pPr algn="r"/>
+                      <a:r>
+                        <a:rPr sz="1100" b="0">
+                          <a:solidFill>
+                            <a:srgbClr val="14213D"/>
+                          </a:solidFill>
+                          <a:latin typeface="Arial"/>
+                        </a:rPr>
+                        <a:t>123</a:t>
                       </a:r>
                     </a:p>
                   </a:txBody>
@@ -18787,30 +19064,30 @@
                           </a:solidFill>
                           <a:latin typeface="Arial"/>
                         </a:rPr>
-                        <a:t>302</a:t>
-                      </a:r>
-                    </a:p>
-                  </a:txBody>
-                  <a:tcPr marL="73152" marR="73152" marT="27432" marB="27432" anchor="ctr">
-                    <a:solidFill>
-                      <a:srgbClr val="F7F6F2"/>
-                    </a:solidFill>
-                  </a:tcPr>
-                </a:tc>
-                <a:tc>
-                  <a:txBody>
-                    <a:bodyPr wrap="square"/>
-                    <a:lstStyle/>
-                    <a:p>
-                      <a:pPr algn="r"/>
-                      <a:r>
-                        <a:rPr sz="1100" b="0">
-                          <a:solidFill>
-                            <a:srgbClr val="14213D"/>
-                          </a:solidFill>
-                          <a:latin typeface="Arial"/>
-                        </a:rPr>
                         <a:t>161</a:t>
+                      </a:r>
+                    </a:p>
+                  </a:txBody>
+                  <a:tcPr marL="73152" marR="73152" marT="27432" marB="27432" anchor="ctr">
+                    <a:solidFill>
+                      <a:srgbClr val="F7F6F2"/>
+                    </a:solidFill>
+                  </a:tcPr>
+                </a:tc>
+                <a:tc>
+                  <a:txBody>
+                    <a:bodyPr wrap="square"/>
+                    <a:lstStyle/>
+                    <a:p>
+                      <a:pPr algn="r"/>
+                      <a:r>
+                        <a:rPr sz="1100" b="0">
+                          <a:solidFill>
+                            <a:srgbClr val="14213D"/>
+                          </a:solidFill>
+                          <a:latin typeface="Arial"/>
+                        </a:rPr>
+                        <a:t>78</a:t>
                       </a:r>
                     </a:p>
                   </a:txBody>
@@ -18973,30 +19250,30 @@
                           </a:solidFill>
                           <a:latin typeface="Arial"/>
                         </a:rPr>
-                        <a:t>185</a:t>
-                      </a:r>
-                    </a:p>
-                  </a:txBody>
-                  <a:tcPr marL="73152" marR="73152" marT="27432" marB="27432" anchor="ctr">
-                    <a:solidFill>
-                      <a:srgbClr val="FFFFFF"/>
-                    </a:solidFill>
-                  </a:tcPr>
-                </a:tc>
-                <a:tc>
-                  <a:txBody>
-                    <a:bodyPr wrap="square"/>
-                    <a:lstStyle/>
-                    <a:p>
-                      <a:pPr algn="r"/>
-                      <a:r>
-                        <a:rPr sz="1100" b="0">
-                          <a:solidFill>
-                            <a:srgbClr val="14213D"/>
-                          </a:solidFill>
-                          <a:latin typeface="Arial"/>
-                        </a:rPr>
                         <a:t>120</a:t>
+                      </a:r>
+                    </a:p>
+                  </a:txBody>
+                  <a:tcPr marL="73152" marR="73152" marT="27432" marB="27432" anchor="ctr">
+                    <a:solidFill>
+                      <a:srgbClr val="FFFFFF"/>
+                    </a:solidFill>
+                  </a:tcPr>
+                </a:tc>
+                <a:tc>
+                  <a:txBody>
+                    <a:bodyPr wrap="square"/>
+                    <a:lstStyle/>
+                    <a:p>
+                      <a:pPr algn="r"/>
+                      <a:r>
+                        <a:rPr sz="1100" b="0">
+                          <a:solidFill>
+                            <a:srgbClr val="14213D"/>
+                          </a:solidFill>
+                          <a:latin typeface="Arial"/>
+                        </a:rPr>
+                        <a:t>50</a:t>
                       </a:r>
                     </a:p>
                   </a:txBody>
@@ -19159,30 +19436,30 @@
                           </a:solidFill>
                           <a:latin typeface="Arial"/>
                         </a:rPr>
-                        <a:t>376</a:t>
-                      </a:r>
-                    </a:p>
-                  </a:txBody>
-                  <a:tcPr marL="73152" marR="73152" marT="27432" marB="27432" anchor="ctr">
-                    <a:solidFill>
-                      <a:srgbClr val="F7F6F2"/>
-                    </a:solidFill>
-                  </a:tcPr>
-                </a:tc>
-                <a:tc>
-                  <a:txBody>
-                    <a:bodyPr wrap="square"/>
-                    <a:lstStyle/>
-                    <a:p>
-                      <a:pPr algn="r"/>
-                      <a:r>
-                        <a:rPr sz="1100" b="0">
-                          <a:solidFill>
-                            <a:srgbClr val="14213D"/>
-                          </a:solidFill>
-                          <a:latin typeface="Arial"/>
-                        </a:rPr>
                         <a:t>326</a:t>
+                      </a:r>
+                    </a:p>
+                  </a:txBody>
+                  <a:tcPr marL="73152" marR="73152" marT="27432" marB="27432" anchor="ctr">
+                    <a:solidFill>
+                      <a:srgbClr val="F7F6F2"/>
+                    </a:solidFill>
+                  </a:tcPr>
+                </a:tc>
+                <a:tc>
+                  <a:txBody>
+                    <a:bodyPr wrap="square"/>
+                    <a:lstStyle/>
+                    <a:p>
+                      <a:pPr algn="r"/>
+                      <a:r>
+                        <a:rPr sz="1100" b="0">
+                          <a:solidFill>
+                            <a:srgbClr val="14213D"/>
+                          </a:solidFill>
+                          <a:latin typeface="Arial"/>
+                        </a:rPr>
+                        <a:t>56</a:t>
                       </a:r>
                     </a:p>
                   </a:txBody>
@@ -19345,30 +19622,30 @@
                           </a:solidFill>
                           <a:latin typeface="Arial"/>
                         </a:rPr>
-                        <a:t>60</a:t>
-                      </a:r>
-                    </a:p>
-                  </a:txBody>
-                  <a:tcPr marL="73152" marR="73152" marT="27432" marB="27432" anchor="ctr">
-                    <a:solidFill>
-                      <a:srgbClr val="FFFFFF"/>
-                    </a:solidFill>
-                  </a:tcPr>
-                </a:tc>
-                <a:tc>
-                  <a:txBody>
-                    <a:bodyPr wrap="square"/>
-                    <a:lstStyle/>
-                    <a:p>
-                      <a:pPr algn="r"/>
-                      <a:r>
-                        <a:rPr sz="1100" b="0">
-                          <a:solidFill>
-                            <a:srgbClr val="14213D"/>
-                          </a:solidFill>
-                          <a:latin typeface="Arial"/>
-                        </a:rPr>
                         <a:t>54</a:t>
+                      </a:r>
+                    </a:p>
+                  </a:txBody>
+                  <a:tcPr marL="73152" marR="73152" marT="27432" marB="27432" anchor="ctr">
+                    <a:solidFill>
+                      <a:srgbClr val="FFFFFF"/>
+                    </a:solidFill>
+                  </a:tcPr>
+                </a:tc>
+                <a:tc>
+                  <a:txBody>
+                    <a:bodyPr wrap="square"/>
+                    <a:lstStyle/>
+                    <a:p>
+                      <a:pPr algn="r"/>
+                      <a:r>
+                        <a:rPr sz="1100" b="0">
+                          <a:solidFill>
+                            <a:srgbClr val="14213D"/>
+                          </a:solidFill>
+                          <a:latin typeface="Arial"/>
+                        </a:rPr>
+                        <a:t>21</a:t>
                       </a:r>
                     </a:p>
                   </a:txBody>
@@ -19531,30 +19808,30 @@
                           </a:solidFill>
                           <a:latin typeface="Arial"/>
                         </a:rPr>
-                        <a:t>147</a:t>
-                      </a:r>
-                    </a:p>
-                  </a:txBody>
-                  <a:tcPr marL="73152" marR="73152" marT="27432" marB="27432" anchor="ctr">
-                    <a:solidFill>
-                      <a:srgbClr val="F7F6F2"/>
-                    </a:solidFill>
-                  </a:tcPr>
-                </a:tc>
-                <a:tc>
-                  <a:txBody>
-                    <a:bodyPr wrap="square"/>
-                    <a:lstStyle/>
-                    <a:p>
-                      <a:pPr algn="r"/>
-                      <a:r>
-                        <a:rPr sz="1100" b="0">
-                          <a:solidFill>
-                            <a:srgbClr val="14213D"/>
-                          </a:solidFill>
-                          <a:latin typeface="Arial"/>
-                        </a:rPr>
                         <a:t>100</a:t>
+                      </a:r>
+                    </a:p>
+                  </a:txBody>
+                  <a:tcPr marL="73152" marR="73152" marT="27432" marB="27432" anchor="ctr">
+                    <a:solidFill>
+                      <a:srgbClr val="F7F6F2"/>
+                    </a:solidFill>
+                  </a:tcPr>
+                </a:tc>
+                <a:tc>
+                  <a:txBody>
+                    <a:bodyPr wrap="square"/>
+                    <a:lstStyle/>
+                    <a:p>
+                      <a:pPr algn="r"/>
+                      <a:r>
+                        <a:rPr sz="1100" b="0">
+                          <a:solidFill>
+                            <a:srgbClr val="14213D"/>
+                          </a:solidFill>
+                          <a:latin typeface="Arial"/>
+                        </a:rPr>
+                        <a:t>31</a:t>
                       </a:r>
                     </a:p>
                   </a:txBody>
@@ -19717,30 +19994,30 @@
                           </a:solidFill>
                           <a:latin typeface="Arial"/>
                         </a:rPr>
-                        <a:t>302</a:t>
-                      </a:r>
-                    </a:p>
-                  </a:txBody>
-                  <a:tcPr marL="73152" marR="73152" marT="27432" marB="27432" anchor="ctr">
-                    <a:solidFill>
-                      <a:srgbClr val="FFFFFF"/>
-                    </a:solidFill>
-                  </a:tcPr>
-                </a:tc>
-                <a:tc>
-                  <a:txBody>
-                    <a:bodyPr wrap="square"/>
-                    <a:lstStyle/>
-                    <a:p>
-                      <a:pPr algn="r"/>
-                      <a:r>
-                        <a:rPr sz="1100" b="0">
-                          <a:solidFill>
-                            <a:srgbClr val="14213D"/>
-                          </a:solidFill>
-                          <a:latin typeface="Arial"/>
-                        </a:rPr>
                         <a:t>245</a:t>
+                      </a:r>
+                    </a:p>
+                  </a:txBody>
+                  <a:tcPr marL="73152" marR="73152" marT="27432" marB="27432" anchor="ctr">
+                    <a:solidFill>
+                      <a:srgbClr val="FFFFFF"/>
+                    </a:solidFill>
+                  </a:tcPr>
+                </a:tc>
+                <a:tc>
+                  <a:txBody>
+                    <a:bodyPr wrap="square"/>
+                    <a:lstStyle/>
+                    <a:p>
+                      <a:pPr algn="r"/>
+                      <a:r>
+                        <a:rPr sz="1100" b="0">
+                          <a:solidFill>
+                            <a:srgbClr val="14213D"/>
+                          </a:solidFill>
+                          <a:latin typeface="Arial"/>
+                        </a:rPr>
+                        <a:t>31</a:t>
                       </a:r>
                     </a:p>
                   </a:txBody>
@@ -19903,30 +20180,30 @@
                           </a:solidFill>
                           <a:latin typeface="Arial"/>
                         </a:rPr>
-                        <a:t>137</a:t>
-                      </a:r>
-                    </a:p>
-                  </a:txBody>
-                  <a:tcPr marL="73152" marR="73152" marT="27432" marB="27432" anchor="ctr">
-                    <a:solidFill>
-                      <a:srgbClr val="F7F6F2"/>
-                    </a:solidFill>
-                  </a:tcPr>
-                </a:tc>
-                <a:tc>
-                  <a:txBody>
-                    <a:bodyPr wrap="square"/>
-                    <a:lstStyle/>
-                    <a:p>
-                      <a:pPr algn="r"/>
-                      <a:r>
-                        <a:rPr sz="1100" b="0">
-                          <a:solidFill>
-                            <a:srgbClr val="14213D"/>
-                          </a:solidFill>
-                          <a:latin typeface="Arial"/>
-                        </a:rPr>
                         <a:t>105</a:t>
+                      </a:r>
+                    </a:p>
+                  </a:txBody>
+                  <a:tcPr marL="73152" marR="73152" marT="27432" marB="27432" anchor="ctr">
+                    <a:solidFill>
+                      <a:srgbClr val="F7F6F2"/>
+                    </a:solidFill>
+                  </a:tcPr>
+                </a:tc>
+                <a:tc>
+                  <a:txBody>
+                    <a:bodyPr wrap="square"/>
+                    <a:lstStyle/>
+                    <a:p>
+                      <a:pPr algn="r"/>
+                      <a:r>
+                        <a:rPr sz="1100" b="0">
+                          <a:solidFill>
+                            <a:srgbClr val="14213D"/>
+                          </a:solidFill>
+                          <a:latin typeface="Arial"/>
+                        </a:rPr>
+                        <a:t>1</a:t>
                       </a:r>
                     </a:p>
                   </a:txBody>
@@ -20089,30 +20366,30 @@
                           </a:solidFill>
                           <a:latin typeface="Arial"/>
                         </a:rPr>
-                        <a:t>207</a:t>
-                      </a:r>
-                    </a:p>
-                  </a:txBody>
-                  <a:tcPr marL="73152" marR="73152" marT="27432" marB="27432" anchor="ctr">
-                    <a:solidFill>
-                      <a:srgbClr val="FFFFFF"/>
-                    </a:solidFill>
-                  </a:tcPr>
-                </a:tc>
-                <a:tc>
-                  <a:txBody>
-                    <a:bodyPr wrap="square"/>
-                    <a:lstStyle/>
-                    <a:p>
-                      <a:pPr algn="r"/>
-                      <a:r>
-                        <a:rPr sz="1100" b="0">
-                          <a:solidFill>
-                            <a:srgbClr val="14213D"/>
-                          </a:solidFill>
-                          <a:latin typeface="Arial"/>
-                        </a:rPr>
                         <a:t>172</a:t>
+                      </a:r>
+                    </a:p>
+                  </a:txBody>
+                  <a:tcPr marL="73152" marR="73152" marT="27432" marB="27432" anchor="ctr">
+                    <a:solidFill>
+                      <a:srgbClr val="FFFFFF"/>
+                    </a:solidFill>
+                  </a:tcPr>
+                </a:tc>
+                <a:tc>
+                  <a:txBody>
+                    <a:bodyPr wrap="square"/>
+                    <a:lstStyle/>
+                    <a:p>
+                      <a:pPr algn="r"/>
+                      <a:r>
+                        <a:rPr sz="1100" b="0">
+                          <a:solidFill>
+                            <a:srgbClr val="14213D"/>
+                          </a:solidFill>
+                          <a:latin typeface="Arial"/>
+                        </a:rPr>
+                        <a:t>40</a:t>
                       </a:r>
                     </a:p>
                   </a:txBody>
@@ -20275,30 +20552,30 @@
                           </a:solidFill>
                           <a:latin typeface="Arial"/>
                         </a:rPr>
-                        <a:t>192</a:t>
-                      </a:r>
-                    </a:p>
-                  </a:txBody>
-                  <a:tcPr marL="73152" marR="73152" marT="27432" marB="27432" anchor="ctr">
-                    <a:solidFill>
-                      <a:srgbClr val="F7F6F2"/>
-                    </a:solidFill>
-                  </a:tcPr>
-                </a:tc>
-                <a:tc>
-                  <a:txBody>
-                    <a:bodyPr wrap="square"/>
-                    <a:lstStyle/>
-                    <a:p>
-                      <a:pPr algn="r"/>
-                      <a:r>
-                        <a:rPr sz="1100" b="0">
-                          <a:solidFill>
-                            <a:srgbClr val="14213D"/>
-                          </a:solidFill>
-                          <a:latin typeface="Arial"/>
-                        </a:rPr>
                         <a:t>111</a:t>
+                      </a:r>
+                    </a:p>
+                  </a:txBody>
+                  <a:tcPr marL="73152" marR="73152" marT="27432" marB="27432" anchor="ctr">
+                    <a:solidFill>
+                      <a:srgbClr val="F7F6F2"/>
+                    </a:solidFill>
+                  </a:tcPr>
+                </a:tc>
+                <a:tc>
+                  <a:txBody>
+                    <a:bodyPr wrap="square"/>
+                    <a:lstStyle/>
+                    <a:p>
+                      <a:pPr algn="r"/>
+                      <a:r>
+                        <a:rPr sz="1100" b="0">
+                          <a:solidFill>
+                            <a:srgbClr val="14213D"/>
+                          </a:solidFill>
+                          <a:latin typeface="Arial"/>
+                        </a:rPr>
+                        <a:t>14</a:t>
                       </a:r>
                     </a:p>
                   </a:txBody>
@@ -20461,30 +20738,30 @@
                           </a:solidFill>
                           <a:latin typeface="Arial"/>
                         </a:rPr>
-                        <a:t>230</a:t>
-                      </a:r>
-                    </a:p>
-                  </a:txBody>
-                  <a:tcPr marL="73152" marR="73152" marT="27432" marB="27432" anchor="ctr">
-                    <a:solidFill>
-                      <a:srgbClr val="FFFFFF"/>
-                    </a:solidFill>
-                  </a:tcPr>
-                </a:tc>
-                <a:tc>
-                  <a:txBody>
-                    <a:bodyPr wrap="square"/>
-                    <a:lstStyle/>
-                    <a:p>
-                      <a:pPr algn="r"/>
-                      <a:r>
-                        <a:rPr sz="1100" b="0">
-                          <a:solidFill>
-                            <a:srgbClr val="14213D"/>
-                          </a:solidFill>
-                          <a:latin typeface="Arial"/>
-                        </a:rPr>
                         <a:t>194</a:t>
+                      </a:r>
+                    </a:p>
+                  </a:txBody>
+                  <a:tcPr marL="73152" marR="73152" marT="27432" marB="27432" anchor="ctr">
+                    <a:solidFill>
+                      <a:srgbClr val="FFFFFF"/>
+                    </a:solidFill>
+                  </a:tcPr>
+                </a:tc>
+                <a:tc>
+                  <a:txBody>
+                    <a:bodyPr wrap="square"/>
+                    <a:lstStyle/>
+                    <a:p>
+                      <a:pPr algn="r"/>
+                      <a:r>
+                        <a:rPr sz="1100" b="0">
+                          <a:solidFill>
+                            <a:srgbClr val="14213D"/>
+                          </a:solidFill>
+                          <a:latin typeface="Arial"/>
+                        </a:rPr>
+                        <a:t>12</a:t>
                       </a:r>
                     </a:p>
                   </a:txBody>
@@ -20647,30 +20924,30 @@
                           </a:solidFill>
                           <a:latin typeface="Arial"/>
                         </a:rPr>
-                        <a:t>163</a:t>
-                      </a:r>
-                    </a:p>
-                  </a:txBody>
-                  <a:tcPr marL="73152" marR="73152" marT="27432" marB="27432" anchor="ctr">
-                    <a:solidFill>
-                      <a:srgbClr val="F7F6F2"/>
-                    </a:solidFill>
-                  </a:tcPr>
-                </a:tc>
-                <a:tc>
-                  <a:txBody>
-                    <a:bodyPr wrap="square"/>
-                    <a:lstStyle/>
-                    <a:p>
-                      <a:pPr algn="r"/>
-                      <a:r>
-                        <a:rPr sz="1100" b="0">
-                          <a:solidFill>
-                            <a:srgbClr val="14213D"/>
-                          </a:solidFill>
-                          <a:latin typeface="Arial"/>
-                        </a:rPr>
                         <a:t>154</a:t>
+                      </a:r>
+                    </a:p>
+                  </a:txBody>
+                  <a:tcPr marL="73152" marR="73152" marT="27432" marB="27432" anchor="ctr">
+                    <a:solidFill>
+                      <a:srgbClr val="F7F6F2"/>
+                    </a:solidFill>
+                  </a:tcPr>
+                </a:tc>
+                <a:tc>
+                  <a:txBody>
+                    <a:bodyPr wrap="square"/>
+                    <a:lstStyle/>
+                    <a:p>
+                      <a:pPr algn="r"/>
+                      <a:r>
+                        <a:rPr sz="1100" b="0">
+                          <a:solidFill>
+                            <a:srgbClr val="14213D"/>
+                          </a:solidFill>
+                          <a:latin typeface="Arial"/>
+                        </a:rPr>
+                        <a:t>41</a:t>
                       </a:r>
                     </a:p>
                   </a:txBody>
@@ -20996,7 +21273,7 @@
                           </a:solidFill>
                           <a:latin typeface="Arial"/>
                         </a:rPr>
-                        <a:t>Conv.</a:t>
+                        <a:t>Leads</a:t>
                       </a:r>
                     </a:p>
                   </a:txBody>
@@ -21019,7 +21296,7 @@
                           </a:solidFill>
                           <a:latin typeface="Arial"/>
                         </a:rPr>
-                        <a:t>Leads</a:t>
+                        <a:t>Booked</a:t>
                       </a:r>
                     </a:p>
                   </a:txBody>
@@ -21182,30 +21459,30 @@
                           </a:solidFill>
                           <a:latin typeface="Arial"/>
                         </a:rPr>
-                        <a:t>39</a:t>
-                      </a:r>
-                    </a:p>
-                  </a:txBody>
-                  <a:tcPr marL="73152" marR="73152" marT="27432" marB="27432" anchor="ctr">
-                    <a:solidFill>
-                      <a:srgbClr val="FFFFFF"/>
-                    </a:solidFill>
-                  </a:tcPr>
-                </a:tc>
-                <a:tc>
-                  <a:txBody>
-                    <a:bodyPr wrap="square"/>
-                    <a:lstStyle/>
-                    <a:p>
-                      <a:pPr algn="r"/>
-                      <a:r>
-                        <a:rPr sz="1100" b="0">
-                          <a:solidFill>
-                            <a:srgbClr val="14213D"/>
-                          </a:solidFill>
-                          <a:latin typeface="Arial"/>
-                        </a:rPr>
                         <a:t>36</a:t>
+                      </a:r>
+                    </a:p>
+                  </a:txBody>
+                  <a:tcPr marL="73152" marR="73152" marT="27432" marB="27432" anchor="ctr">
+                    <a:solidFill>
+                      <a:srgbClr val="FFFFFF"/>
+                    </a:solidFill>
+                  </a:tcPr>
+                </a:tc>
+                <a:tc>
+                  <a:txBody>
+                    <a:bodyPr wrap="square"/>
+                    <a:lstStyle/>
+                    <a:p>
+                      <a:pPr algn="r"/>
+                      <a:r>
+                        <a:rPr sz="1100" b="0">
+                          <a:solidFill>
+                            <a:srgbClr val="14213D"/>
+                          </a:solidFill>
+                          <a:latin typeface="Arial"/>
+                        </a:rPr>
+                        <a:t>8</a:t>
                       </a:r>
                     </a:p>
                   </a:txBody>
@@ -21368,30 +21645,30 @@
                           </a:solidFill>
                           <a:latin typeface="Arial"/>
                         </a:rPr>
-                        <a:t>89</a:t>
-                      </a:r>
-                    </a:p>
-                  </a:txBody>
-                  <a:tcPr marL="73152" marR="73152" marT="27432" marB="27432" anchor="ctr">
-                    <a:solidFill>
-                      <a:srgbClr val="F7F6F2"/>
-                    </a:solidFill>
-                  </a:tcPr>
-                </a:tc>
-                <a:tc>
-                  <a:txBody>
-                    <a:bodyPr wrap="square"/>
-                    <a:lstStyle/>
-                    <a:p>
-                      <a:pPr algn="r"/>
-                      <a:r>
-                        <a:rPr sz="1100" b="0">
-                          <a:solidFill>
-                            <a:srgbClr val="14213D"/>
-                          </a:solidFill>
-                          <a:latin typeface="Arial"/>
-                        </a:rPr>
                         <a:t>74</a:t>
+                      </a:r>
+                    </a:p>
+                  </a:txBody>
+                  <a:tcPr marL="73152" marR="73152" marT="27432" marB="27432" anchor="ctr">
+                    <a:solidFill>
+                      <a:srgbClr val="F7F6F2"/>
+                    </a:solidFill>
+                  </a:tcPr>
+                </a:tc>
+                <a:tc>
+                  <a:txBody>
+                    <a:bodyPr wrap="square"/>
+                    <a:lstStyle/>
+                    <a:p>
+                      <a:pPr algn="r"/>
+                      <a:r>
+                        <a:rPr sz="1100" b="0">
+                          <a:solidFill>
+                            <a:srgbClr val="14213D"/>
+                          </a:solidFill>
+                          <a:latin typeface="Arial"/>
+                        </a:rPr>
+                        <a:t>20</a:t>
                       </a:r>
                     </a:p>
                   </a:txBody>
@@ -21554,30 +21831,30 @@
                           </a:solidFill>
                           <a:latin typeface="Arial"/>
                         </a:rPr>
-                        <a:t>172</a:t>
-                      </a:r>
-                    </a:p>
-                  </a:txBody>
-                  <a:tcPr marL="73152" marR="73152" marT="27432" marB="27432" anchor="ctr">
-                    <a:solidFill>
-                      <a:srgbClr val="FFFFFF"/>
-                    </a:solidFill>
-                  </a:tcPr>
-                </a:tc>
-                <a:tc>
-                  <a:txBody>
-                    <a:bodyPr wrap="square"/>
-                    <a:lstStyle/>
-                    <a:p>
-                      <a:pPr algn="r"/>
-                      <a:r>
-                        <a:rPr sz="1100" b="0">
-                          <a:solidFill>
-                            <a:srgbClr val="14213D"/>
-                          </a:solidFill>
-                          <a:latin typeface="Arial"/>
-                        </a:rPr>
                         <a:t>14</a:t>
+                      </a:r>
+                    </a:p>
+                  </a:txBody>
+                  <a:tcPr marL="73152" marR="73152" marT="27432" marB="27432" anchor="ctr">
+                    <a:solidFill>
+                      <a:srgbClr val="FFFFFF"/>
+                    </a:solidFill>
+                  </a:tcPr>
+                </a:tc>
+                <a:tc>
+                  <a:txBody>
+                    <a:bodyPr wrap="square"/>
+                    <a:lstStyle/>
+                    <a:p>
+                      <a:pPr algn="r"/>
+                      <a:r>
+                        <a:rPr sz="1100" b="0">
+                          <a:solidFill>
+                            <a:srgbClr val="14213D"/>
+                          </a:solidFill>
+                          <a:latin typeface="Arial"/>
+                        </a:rPr>
+                        <a:t>4</a:t>
                       </a:r>
                     </a:p>
                   </a:txBody>
@@ -21740,30 +22017,30 @@
                           </a:solidFill>
                           <a:latin typeface="Arial"/>
                         </a:rPr>
-                        <a:t>67</a:t>
-                      </a:r>
-                    </a:p>
-                  </a:txBody>
-                  <a:tcPr marL="73152" marR="73152" marT="27432" marB="27432" anchor="ctr">
-                    <a:solidFill>
-                      <a:srgbClr val="F7F6F2"/>
-                    </a:solidFill>
-                  </a:tcPr>
-                </a:tc>
-                <a:tc>
-                  <a:txBody>
-                    <a:bodyPr wrap="square"/>
-                    <a:lstStyle/>
-                    <a:p>
-                      <a:pPr algn="r"/>
-                      <a:r>
-                        <a:rPr sz="1100" b="0">
-                          <a:solidFill>
-                            <a:srgbClr val="14213D"/>
-                          </a:solidFill>
-                          <a:latin typeface="Arial"/>
-                        </a:rPr>
                         <a:t>62</a:t>
+                      </a:r>
+                    </a:p>
+                  </a:txBody>
+                  <a:tcPr marL="73152" marR="73152" marT="27432" marB="27432" anchor="ctr">
+                    <a:solidFill>
+                      <a:srgbClr val="F7F6F2"/>
+                    </a:solidFill>
+                  </a:tcPr>
+                </a:tc>
+                <a:tc>
+                  <a:txBody>
+                    <a:bodyPr wrap="square"/>
+                    <a:lstStyle/>
+                    <a:p>
+                      <a:pPr algn="r"/>
+                      <a:r>
+                        <a:rPr sz="1100" b="0">
+                          <a:solidFill>
+                            <a:srgbClr val="14213D"/>
+                          </a:solidFill>
+                          <a:latin typeface="Arial"/>
+                        </a:rPr>
+                        <a:t>15</a:t>
                       </a:r>
                     </a:p>
                   </a:txBody>
@@ -21926,30 +22203,30 @@
                           </a:solidFill>
                           <a:latin typeface="Arial"/>
                         </a:rPr>
-                        <a:t>55</a:t>
-                      </a:r>
-                    </a:p>
-                  </a:txBody>
-                  <a:tcPr marL="73152" marR="73152" marT="27432" marB="27432" anchor="ctr">
-                    <a:solidFill>
-                      <a:srgbClr val="FFFFFF"/>
-                    </a:solidFill>
-                  </a:tcPr>
-                </a:tc>
-                <a:tc>
-                  <a:txBody>
-                    <a:bodyPr wrap="square"/>
-                    <a:lstStyle/>
-                    <a:p>
-                      <a:pPr algn="r"/>
-                      <a:r>
-                        <a:rPr sz="1100" b="0">
-                          <a:solidFill>
-                            <a:srgbClr val="14213D"/>
-                          </a:solidFill>
-                          <a:latin typeface="Arial"/>
-                        </a:rPr>
                         <a:t>12</a:t>
+                      </a:r>
+                    </a:p>
+                  </a:txBody>
+                  <a:tcPr marL="73152" marR="73152" marT="27432" marB="27432" anchor="ctr">
+                    <a:solidFill>
+                      <a:srgbClr val="FFFFFF"/>
+                    </a:solidFill>
+                  </a:tcPr>
+                </a:tc>
+                <a:tc>
+                  <a:txBody>
+                    <a:bodyPr wrap="square"/>
+                    <a:lstStyle/>
+                    <a:p>
+                      <a:pPr algn="r"/>
+                      <a:r>
+                        <a:rPr sz="1100" b="0">
+                          <a:solidFill>
+                            <a:srgbClr val="14213D"/>
+                          </a:solidFill>
+                          <a:latin typeface="Arial"/>
+                        </a:rPr>
+                        <a:t>6</a:t>
                       </a:r>
                     </a:p>
                   </a:txBody>
@@ -22112,30 +22389,30 @@
                           </a:solidFill>
                           <a:latin typeface="Arial"/>
                         </a:rPr>
-                        <a:t>33</a:t>
-                      </a:r>
-                    </a:p>
-                  </a:txBody>
-                  <a:tcPr marL="73152" marR="73152" marT="27432" marB="27432" anchor="ctr">
-                    <a:solidFill>
-                      <a:srgbClr val="F7F6F2"/>
-                    </a:solidFill>
-                  </a:tcPr>
-                </a:tc>
-                <a:tc>
-                  <a:txBody>
-                    <a:bodyPr wrap="square"/>
-                    <a:lstStyle/>
-                    <a:p>
-                      <a:pPr algn="r"/>
-                      <a:r>
-                        <a:rPr sz="1100" b="0">
-                          <a:solidFill>
-                            <a:srgbClr val="14213D"/>
-                          </a:solidFill>
-                          <a:latin typeface="Arial"/>
-                        </a:rPr>
                         <a:t>24</a:t>
+                      </a:r>
+                    </a:p>
+                  </a:txBody>
+                  <a:tcPr marL="73152" marR="73152" marT="27432" marB="27432" anchor="ctr">
+                    <a:solidFill>
+                      <a:srgbClr val="F7F6F2"/>
+                    </a:solidFill>
+                  </a:tcPr>
+                </a:tc>
+                <a:tc>
+                  <a:txBody>
+                    <a:bodyPr wrap="square"/>
+                    <a:lstStyle/>
+                    <a:p>
+                      <a:pPr algn="r"/>
+                      <a:r>
+                        <a:rPr sz="1100" b="0">
+                          <a:solidFill>
+                            <a:srgbClr val="14213D"/>
+                          </a:solidFill>
+                          <a:latin typeface="Arial"/>
+                        </a:rPr>
+                        <a:t>7</a:t>
                       </a:r>
                     </a:p>
                   </a:txBody>
@@ -22298,30 +22575,30 @@
                           </a:solidFill>
                           <a:latin typeface="Arial"/>
                         </a:rPr>
-                        <a:t>31</a:t>
-                      </a:r>
-                    </a:p>
-                  </a:txBody>
-                  <a:tcPr marL="73152" marR="73152" marT="27432" marB="27432" anchor="ctr">
-                    <a:solidFill>
-                      <a:srgbClr val="FFFFFF"/>
-                    </a:solidFill>
-                  </a:tcPr>
-                </a:tc>
-                <a:tc>
-                  <a:txBody>
-                    <a:bodyPr wrap="square"/>
-                    <a:lstStyle/>
-                    <a:p>
-                      <a:pPr algn="r"/>
-                      <a:r>
-                        <a:rPr sz="1100" b="0">
-                          <a:solidFill>
-                            <a:srgbClr val="14213D"/>
-                          </a:solidFill>
-                          <a:latin typeface="Arial"/>
-                        </a:rPr>
                         <a:t>25</a:t>
+                      </a:r>
+                    </a:p>
+                  </a:txBody>
+                  <a:tcPr marL="73152" marR="73152" marT="27432" marB="27432" anchor="ctr">
+                    <a:solidFill>
+                      <a:srgbClr val="FFFFFF"/>
+                    </a:solidFill>
+                  </a:tcPr>
+                </a:tc>
+                <a:tc>
+                  <a:txBody>
+                    <a:bodyPr wrap="square"/>
+                    <a:lstStyle/>
+                    <a:p>
+                      <a:pPr algn="r"/>
+                      <a:r>
+                        <a:rPr sz="1100" b="0">
+                          <a:solidFill>
+                            <a:srgbClr val="14213D"/>
+                          </a:solidFill>
+                          <a:latin typeface="Arial"/>
+                        </a:rPr>
+                        <a:t>6</a:t>
                       </a:r>
                     </a:p>
                   </a:txBody>
@@ -22484,30 +22761,30 @@
                           </a:solidFill>
                           <a:latin typeface="Arial"/>
                         </a:rPr>
-                        <a:t>41</a:t>
-                      </a:r>
-                    </a:p>
-                  </a:txBody>
-                  <a:tcPr marL="73152" marR="73152" marT="27432" marB="27432" anchor="ctr">
-                    <a:solidFill>
-                      <a:srgbClr val="F7F6F2"/>
-                    </a:solidFill>
-                  </a:tcPr>
-                </a:tc>
-                <a:tc>
-                  <a:txBody>
-                    <a:bodyPr wrap="square"/>
-                    <a:lstStyle/>
-                    <a:p>
-                      <a:pPr algn="r"/>
-                      <a:r>
-                        <a:rPr sz="1100" b="0">
-                          <a:solidFill>
-                            <a:srgbClr val="14213D"/>
-                          </a:solidFill>
-                          <a:latin typeface="Arial"/>
-                        </a:rPr>
                         <a:t>27</a:t>
+                      </a:r>
+                    </a:p>
+                  </a:txBody>
+                  <a:tcPr marL="73152" marR="73152" marT="27432" marB="27432" anchor="ctr">
+                    <a:solidFill>
+                      <a:srgbClr val="F7F6F2"/>
+                    </a:solidFill>
+                  </a:tcPr>
+                </a:tc>
+                <a:tc>
+                  <a:txBody>
+                    <a:bodyPr wrap="square"/>
+                    <a:lstStyle/>
+                    <a:p>
+                      <a:pPr algn="r"/>
+                      <a:r>
+                        <a:rPr sz="1100" b="0">
+                          <a:solidFill>
+                            <a:srgbClr val="14213D"/>
+                          </a:solidFill>
+                          <a:latin typeface="Arial"/>
+                        </a:rPr>
+                        <a:t>10</a:t>
                       </a:r>
                     </a:p>
                   </a:txBody>
@@ -22670,30 +22947,30 @@
                           </a:solidFill>
                           <a:latin typeface="Arial"/>
                         </a:rPr>
-                        <a:t>12</a:t>
-                      </a:r>
-                    </a:p>
-                  </a:txBody>
-                  <a:tcPr marL="73152" marR="73152" marT="27432" marB="27432" anchor="ctr">
-                    <a:solidFill>
-                      <a:srgbClr val="FFFFFF"/>
-                    </a:solidFill>
-                  </a:tcPr>
-                </a:tc>
-                <a:tc>
-                  <a:txBody>
-                    <a:bodyPr wrap="square"/>
-                    <a:lstStyle/>
-                    <a:p>
-                      <a:pPr algn="r"/>
-                      <a:r>
-                        <a:rPr sz="1100" b="0">
-                          <a:solidFill>
-                            <a:srgbClr val="14213D"/>
-                          </a:solidFill>
-                          <a:latin typeface="Arial"/>
-                        </a:rPr>
                         <a:t>11</a:t>
+                      </a:r>
+                    </a:p>
+                  </a:txBody>
+                  <a:tcPr marL="73152" marR="73152" marT="27432" marB="27432" anchor="ctr">
+                    <a:solidFill>
+                      <a:srgbClr val="FFFFFF"/>
+                    </a:solidFill>
+                  </a:tcPr>
+                </a:tc>
+                <a:tc>
+                  <a:txBody>
+                    <a:bodyPr wrap="square"/>
+                    <a:lstStyle/>
+                    <a:p>
+                      <a:pPr algn="r"/>
+                      <a:r>
+                        <a:rPr sz="1100" b="0">
+                          <a:solidFill>
+                            <a:srgbClr val="14213D"/>
+                          </a:solidFill>
+                          <a:latin typeface="Arial"/>
+                        </a:rPr>
+                        <a:t>1</a:t>
                       </a:r>
                     </a:p>
                   </a:txBody>
@@ -22856,7 +23133,7 @@
                           </a:solidFill>
                           <a:latin typeface="Arial"/>
                         </a:rPr>
-                        <a:t>0</a:t>
+                        <a:t>1</a:t>
                       </a:r>
                     </a:p>
                   </a:txBody>
@@ -23042,30 +23319,30 @@
                           </a:solidFill>
                           <a:latin typeface="Arial"/>
                         </a:rPr>
-                        <a:t>23</a:t>
-                      </a:r>
-                    </a:p>
-                  </a:txBody>
-                  <a:tcPr marL="73152" marR="73152" marT="27432" marB="27432" anchor="ctr">
-                    <a:solidFill>
-                      <a:srgbClr val="FFFFFF"/>
-                    </a:solidFill>
-                  </a:tcPr>
-                </a:tc>
-                <a:tc>
-                  <a:txBody>
-                    <a:bodyPr wrap="square"/>
-                    <a:lstStyle/>
-                    <a:p>
-                      <a:pPr algn="r"/>
-                      <a:r>
-                        <a:rPr sz="1100" b="0">
-                          <a:solidFill>
-                            <a:srgbClr val="14213D"/>
-                          </a:solidFill>
-                          <a:latin typeface="Arial"/>
-                        </a:rPr>
                         <a:t>21</a:t>
+                      </a:r>
+                    </a:p>
+                  </a:txBody>
+                  <a:tcPr marL="73152" marR="73152" marT="27432" marB="27432" anchor="ctr">
+                    <a:solidFill>
+                      <a:srgbClr val="FFFFFF"/>
+                    </a:solidFill>
+                  </a:tcPr>
+                </a:tc>
+                <a:tc>
+                  <a:txBody>
+                    <a:bodyPr wrap="square"/>
+                    <a:lstStyle/>
+                    <a:p>
+                      <a:pPr algn="r"/>
+                      <a:r>
+                        <a:rPr sz="1100" b="0">
+                          <a:solidFill>
+                            <a:srgbClr val="14213D"/>
+                          </a:solidFill>
+                          <a:latin typeface="Arial"/>
+                        </a:rPr>
+                        <a:t>8</a:t>
                       </a:r>
                     </a:p>
                   </a:txBody>
@@ -23228,30 +23505,30 @@
                           </a:solidFill>
                           <a:latin typeface="Arial"/>
                         </a:rPr>
-                        <a:t>67</a:t>
-                      </a:r>
-                    </a:p>
-                  </a:txBody>
-                  <a:tcPr marL="73152" marR="73152" marT="27432" marB="27432" anchor="ctr">
-                    <a:solidFill>
-                      <a:srgbClr val="F7F6F2"/>
-                    </a:solidFill>
-                  </a:tcPr>
-                </a:tc>
-                <a:tc>
-                  <a:txBody>
-                    <a:bodyPr wrap="square"/>
-                    <a:lstStyle/>
-                    <a:p>
-                      <a:pPr algn="r"/>
-                      <a:r>
-                        <a:rPr sz="1100" b="0">
-                          <a:solidFill>
-                            <a:srgbClr val="14213D"/>
-                          </a:solidFill>
-                          <a:latin typeface="Arial"/>
-                        </a:rPr>
                         <a:t>47</a:t>
+                      </a:r>
+                    </a:p>
+                  </a:txBody>
+                  <a:tcPr marL="73152" marR="73152" marT="27432" marB="27432" anchor="ctr">
+                    <a:solidFill>
+                      <a:srgbClr val="F7F6F2"/>
+                    </a:solidFill>
+                  </a:tcPr>
+                </a:tc>
+                <a:tc>
+                  <a:txBody>
+                    <a:bodyPr wrap="square"/>
+                    <a:lstStyle/>
+                    <a:p>
+                      <a:pPr algn="r"/>
+                      <a:r>
+                        <a:rPr sz="1100" b="0">
+                          <a:solidFill>
+                            <a:srgbClr val="14213D"/>
+                          </a:solidFill>
+                          <a:latin typeface="Arial"/>
+                        </a:rPr>
+                        <a:t>8</a:t>
                       </a:r>
                     </a:p>
                   </a:txBody>
@@ -23414,30 +23691,30 @@
                           </a:solidFill>
                           <a:latin typeface="Arial"/>
                         </a:rPr>
-                        <a:t>10</a:t>
-                      </a:r>
-                    </a:p>
-                  </a:txBody>
-                  <a:tcPr marL="73152" marR="73152" marT="27432" marB="27432" anchor="ctr">
-                    <a:solidFill>
-                      <a:srgbClr val="FFFFFF"/>
-                    </a:solidFill>
-                  </a:tcPr>
-                </a:tc>
-                <a:tc>
-                  <a:txBody>
-                    <a:bodyPr wrap="square"/>
-                    <a:lstStyle/>
-                    <a:p>
-                      <a:pPr algn="r"/>
-                      <a:r>
-                        <a:rPr sz="1100" b="0">
-                          <a:solidFill>
-                            <a:srgbClr val="14213D"/>
-                          </a:solidFill>
-                          <a:latin typeface="Arial"/>
-                        </a:rPr>
                         <a:t>9</a:t>
+                      </a:r>
+                    </a:p>
+                  </a:txBody>
+                  <a:tcPr marL="73152" marR="73152" marT="27432" marB="27432" anchor="ctr">
+                    <a:solidFill>
+                      <a:srgbClr val="FFFFFF"/>
+                    </a:solidFill>
+                  </a:tcPr>
+                </a:tc>
+                <a:tc>
+                  <a:txBody>
+                    <a:bodyPr wrap="square"/>
+                    <a:lstStyle/>
+                    <a:p>
+                      <a:pPr algn="r"/>
+                      <a:r>
+                        <a:rPr sz="1100" b="0">
+                          <a:solidFill>
+                            <a:srgbClr val="14213D"/>
+                          </a:solidFill>
+                          <a:latin typeface="Arial"/>
+                        </a:rPr>
+                        <a:t>5</a:t>
                       </a:r>
                     </a:p>
                   </a:txBody>
@@ -23600,7 +23877,7 @@
                           </a:solidFill>
                           <a:latin typeface="Arial"/>
                         </a:rPr>
-                        <a:t>5</a:t>
+                        <a:t>2</a:t>
                       </a:r>
                     </a:p>
                   </a:txBody>

</xml_diff>

<commit_message>
Add Charleston Marketing (ROI Marketing, Apr–Sep) slide as slide 5
Co-Authored-By: Claude Opus 5.5 <noreply@anthropic.com>
Claude-Session: https://claude.ai/code/session_015KGeERGX8tZXyoMsdSGKK4
</commit_message>
<xml_diff>
--- a/Coastal-Air-Plus-YTD-Performance-Oct23-2026.pptx
+++ b/Coastal-Air-Plus-YTD-Performance-Oct23-2026.pptx
@@ -9,6 +9,7 @@
     <p:sldId id="270" r:id="rId22"/>
     <p:sldId id="268" r:id="rId20"/>
     <p:sldId id="272" r:id="rId24"/>
+    <p:sldId id="283" r:id="rId23"/>
     <p:sldId id="269" r:id="rId21"/>
     <p:sldId id="273" r:id="rId25"/>
     <p:sldId id="274" r:id="rId26"/>
@@ -587,6 +588,76 @@
           <a:p>
             <a:r>
               <a:t>Digital closed revenue from Searchlight is $841,452 for January 1 to October 23. Brand-assisted revenue, about $225,000, is an estimate of revenue from customers who first called the main line and later came back through the website, Google listings or ads; Searchlight credits it to the main line, so it is not in the $841,452. Together that is about $1.07 million in marketing-influenced revenue. Adding $94,000 from LettrLabs direct mail brings the total to $1,160,452. Searchlight's digital figure already includes $1,627 from two campaigns named Direct Mail; the LettrLabs amount is reported separately and may cover a different date range.</a:t>
+            </a:r>
+          </a:p>
+        </p:txBody>
+      </p:sp>
+      <p:sp>
+        <p:nvSpPr>
+          <p:cNvPr id="4" name="Slide Number Placeholder 3"/>
+          <p:cNvSpPr>
+            <a:spLocks noGrp="1"/>
+          </p:cNvSpPr>
+          <p:nvPr>
+            <p:ph type="sldNum" idx="5" sz="quarter"/>
+          </p:nvPr>
+        </p:nvSpPr>
+        <p:spPr/>
+      </p:sp>
+    </p:spTree>
+  </p:cSld>
+  <p:clrMapOvr>
+    <a:masterClrMapping/>
+  </p:clrMapOvr>
+</p:notes>
+</file>
+
+<file path=ppt/notesSlides/notesSlide14.xml><?xml version="1.0" encoding="utf-8"?>
+<p:notes xmlns:a="http://schemas.openxmlformats.org/drawingml/2006/main" xmlns:p="http://schemas.openxmlformats.org/presentationml/2006/main" xmlns:r="http://schemas.openxmlformats.org/officeDocument/2006/relationships">
+  <p:cSld>
+    <p:spTree>
+      <p:nvGrpSpPr>
+        <p:cNvPr id="1" name=""/>
+        <p:cNvGrpSpPr/>
+        <p:nvPr/>
+      </p:nvGrpSpPr>
+      <p:grpSpPr>
+        <a:xfrm>
+          <a:off x="0" y="0"/>
+          <a:ext cx="0" cy="0"/>
+          <a:chOff x="0" y="0"/>
+          <a:chExt cx="0" cy="0"/>
+        </a:xfrm>
+      </p:grpSpPr>
+      <p:sp>
+        <p:nvSpPr>
+          <p:cNvPr id="2" name="Slide Image Placeholder 1"/>
+          <p:cNvSpPr>
+            <a:spLocks noGrp="1"/>
+          </p:cNvSpPr>
+          <p:nvPr>
+            <p:ph type="sldImg" idx="2"/>
+          </p:nvPr>
+        </p:nvSpPr>
+        <p:spPr/>
+      </p:sp>
+      <p:sp>
+        <p:nvSpPr>
+          <p:cNvPr id="3" name="Notes Placeholder 2"/>
+          <p:cNvSpPr>
+            <a:spLocks noGrp="1"/>
+          </p:cNvSpPr>
+          <p:nvPr>
+            <p:ph type="body" idx="3" sz="quarter"/>
+          </p:nvPr>
+        </p:nvSpPr>
+        <p:spPr/>
+        <p:txBody>
+          <a:bodyPr/>
+          <a:lstStyle/>
+          <a:p>
+            <a:r>
+              <a:t>Charleston marketing managed by ROI Marketing, April through September 2026: $144,496 ad spend, 969 qualified leads at $149 per lead, 346 booked jobs and $244,807 in revenue. These figures were provided separately and are not from Searchlight.</a:t>
             </a:r>
           </a:p>
         </p:txBody>
@@ -4648,7 +4719,7 @@
                 </a:solidFill>
                 <a:latin typeface="Arial"/>
               </a:rPr>
-              <a:t>10</a:t>
+              <a:t>11</a:t>
             </a:r>
           </a:p>
         </p:txBody>
@@ -6069,7 +6140,7 @@
                 </a:solidFill>
                 <a:latin typeface="Arial"/>
               </a:rPr>
-              <a:t>11</a:t>
+              <a:t>12</a:t>
             </a:r>
           </a:p>
         </p:txBody>
@@ -9022,7 +9093,7 @@
                 </a:solidFill>
                 <a:latin typeface="Arial"/>
               </a:rPr>
-              <a:t>12</a:t>
+              <a:t>13</a:t>
             </a:r>
           </a:p>
         </p:txBody>
@@ -11975,7 +12046,7 @@
                 </a:solidFill>
                 <a:latin typeface="Arial"/>
               </a:rPr>
-              <a:t>13</a:t>
+              <a:t>14</a:t>
             </a:r>
           </a:p>
         </p:txBody>
@@ -14928,7 +14999,7 @@
                 </a:solidFill>
                 <a:latin typeface="Arial"/>
               </a:rPr>
-              <a:t>14</a:t>
+              <a:t>15</a:t>
             </a:r>
           </a:p>
         </p:txBody>
@@ -18278,6 +18349,792 @@
                 <a:latin typeface="Arial"/>
               </a:rPr>
               <a:t>Jobs booked in October keep closing over the coming weeks, so recent campaigns and October offers may still add revenue.</a:t>
+            </a:r>
+          </a:p>
+        </p:txBody>
+      </p:sp>
+    </p:spTree>
+  </p:cSld>
+  <p:clrMapOvr>
+    <a:masterClrMapping/>
+  </p:clrMapOvr>
+</p:sld>
+</file>
+
+<file path=ppt/slides/slide16.xml><?xml version="1.0" encoding="utf-8"?>
+<p:sld xmlns:a="http://schemas.openxmlformats.org/drawingml/2006/main" xmlns:p="http://schemas.openxmlformats.org/presentationml/2006/main" xmlns:r="http://schemas.openxmlformats.org/officeDocument/2006/relationships">
+  <p:cSld>
+    <p:bg>
+      <p:bgPr>
+        <a:solidFill>
+          <a:srgbClr val="F7F6F2"/>
+        </a:solidFill>
+        <a:effectLst/>
+      </p:bgPr>
+    </p:bg>
+    <p:spTree>
+      <p:nvGrpSpPr>
+        <p:cNvPr id="1" name=""/>
+        <p:cNvGrpSpPr/>
+        <p:nvPr/>
+      </p:nvGrpSpPr>
+      <p:grpSpPr/>
+      <p:sp>
+        <p:nvSpPr>
+          <p:cNvPr id="2" name="Title"/>
+          <p:cNvSpPr txBox="1"/>
+          <p:nvPr/>
+        </p:nvSpPr>
+        <p:spPr>
+          <a:xfrm>
+            <a:off x="548640" y="411480"/>
+            <a:ext cx="11094415" cy="548640"/>
+          </a:xfrm>
+          <a:prstGeom prst="rect">
+            <a:avLst/>
+          </a:prstGeom>
+          <a:noFill/>
+        </p:spPr>
+        <p:txBody>
+          <a:bodyPr wrap="square" lIns="0" rIns="0" tIns="0" bIns="0">
+            <a:spAutoFit/>
+          </a:bodyPr>
+          <a:lstStyle/>
+          <a:p>
+            <a:pPr algn="l"/>
+            <a:r>
+              <a:rPr sz="2800" b="1">
+                <a:solidFill>
+                  <a:srgbClr val="14213D"/>
+                </a:solidFill>
+                <a:latin typeface="Arial"/>
+              </a:rPr>
+              <a:t>Charleston Marketing</a:t>
+            </a:r>
+          </a:p>
+        </p:txBody>
+      </p:sp>
+      <p:sp>
+        <p:nvSpPr>
+          <p:cNvPr id="3" name="Subtitle"/>
+          <p:cNvSpPr txBox="1"/>
+          <p:nvPr/>
+        </p:nvSpPr>
+        <p:spPr>
+          <a:xfrm>
+            <a:off x="548640" y="960120"/>
+            <a:ext cx="11094415" cy="365760"/>
+          </a:xfrm>
+          <a:prstGeom prst="rect">
+            <a:avLst/>
+          </a:prstGeom>
+          <a:noFill/>
+        </p:spPr>
+        <p:txBody>
+          <a:bodyPr wrap="square" lIns="0" rIns="0" tIns="0" bIns="0">
+            <a:spAutoFit/>
+          </a:bodyPr>
+          <a:lstStyle/>
+          <a:p>
+            <a:pPr algn="l"/>
+            <a:r>
+              <a:rPr sz="1800" b="1">
+                <a:solidFill>
+                  <a:srgbClr val="1F6676"/>
+                </a:solidFill>
+                <a:latin typeface="Arial"/>
+              </a:rPr>
+              <a:t>ROI Marketing</a:t>
+            </a:r>
+          </a:p>
+        </p:txBody>
+      </p:sp>
+      <p:sp>
+        <p:nvSpPr>
+          <p:cNvPr id="4" name="Period"/>
+          <p:cNvSpPr txBox="1"/>
+          <p:nvPr/>
+        </p:nvSpPr>
+        <p:spPr>
+          <a:xfrm>
+            <a:off x="548640" y="1371600"/>
+            <a:ext cx="11094415" cy="274320"/>
+          </a:xfrm>
+          <a:prstGeom prst="rect">
+            <a:avLst/>
+          </a:prstGeom>
+          <a:noFill/>
+        </p:spPr>
+        <p:txBody>
+          <a:bodyPr wrap="square" lIns="0" rIns="0" tIns="0" bIns="0">
+            <a:spAutoFit/>
+          </a:bodyPr>
+          <a:lstStyle/>
+          <a:p>
+            <a:pPr algn="l"/>
+            <a:r>
+              <a:rPr sz="1200" b="1">
+                <a:solidFill>
+                  <a:srgbClr val="5A6478"/>
+                </a:solidFill>
+                <a:latin typeface="Arial"/>
+              </a:rPr>
+              <a:t>APRIL – SEPTEMBER 2026</a:t>
+            </a:r>
+          </a:p>
+        </p:txBody>
+      </p:sp>
+      <p:sp>
+        <p:nvSpPr>
+          <p:cNvPr id="5" name="Stat Ad Spend"/>
+          <p:cNvSpPr/>
+          <p:nvPr/>
+        </p:nvSpPr>
+        <p:spPr>
+          <a:xfrm>
+            <a:off x="548640" y="1874519"/>
+            <a:ext cx="3515258" cy="1828800"/>
+          </a:xfrm>
+          <a:prstGeom prst="roundRect">
+            <a:avLst>
+              <a:gd name="adj" fmla="val 5000"/>
+            </a:avLst>
+          </a:prstGeom>
+          <a:solidFill>
+            <a:srgbClr val="FFFFFF"/>
+          </a:solidFill>
+          <a:ln w="9525">
+            <a:solidFill>
+              <a:srgbClr val="E2E0D8"/>
+            </a:solidFill>
+          </a:ln>
+        </p:spPr>
+        <p:style>
+          <a:lnRef idx="1">
+            <a:schemeClr val="accent1"/>
+          </a:lnRef>
+          <a:fillRef idx="3">
+            <a:schemeClr val="accent1"/>
+          </a:fillRef>
+          <a:effectRef idx="2">
+            <a:schemeClr val="accent1"/>
+          </a:effectRef>
+          <a:fontRef idx="minor">
+            <a:schemeClr val="lt1"/>
+          </a:fontRef>
+        </p:style>
+        <p:txBody>
+          <a:bodyPr rtlCol="0" anchor="ctr"/>
+          <a:lstStyle/>
+          <a:p>
+            <a:pPr algn="ctr"/>
+          </a:p>
+        </p:txBody>
+      </p:sp>
+      <p:sp>
+        <p:nvSpPr>
+          <p:cNvPr id="6" name="Text"/>
+          <p:cNvSpPr txBox="1"/>
+          <p:nvPr/>
+        </p:nvSpPr>
+        <p:spPr>
+          <a:xfrm>
+            <a:off x="868680" y="2148839"/>
+            <a:ext cx="2875178" cy="274320"/>
+          </a:xfrm>
+          <a:prstGeom prst="rect">
+            <a:avLst/>
+          </a:prstGeom>
+          <a:noFill/>
+        </p:spPr>
+        <p:txBody>
+          <a:bodyPr wrap="square" lIns="0" rIns="0" tIns="0" bIns="0">
+            <a:spAutoFit/>
+          </a:bodyPr>
+          <a:lstStyle/>
+          <a:p>
+            <a:pPr algn="l"/>
+            <a:r>
+              <a:rPr sz="1200" b="1">
+                <a:solidFill>
+                  <a:srgbClr val="5A6478"/>
+                </a:solidFill>
+                <a:latin typeface="Arial"/>
+              </a:rPr>
+              <a:t>AD SPEND</a:t>
+            </a:r>
+          </a:p>
+        </p:txBody>
+      </p:sp>
+      <p:sp>
+        <p:nvSpPr>
+          <p:cNvPr id="7" name="Text"/>
+          <p:cNvSpPr txBox="1"/>
+          <p:nvPr/>
+        </p:nvSpPr>
+        <p:spPr>
+          <a:xfrm>
+            <a:off x="868680" y="2560320"/>
+            <a:ext cx="2875178" cy="822960"/>
+          </a:xfrm>
+          <a:prstGeom prst="rect">
+            <a:avLst/>
+          </a:prstGeom>
+          <a:noFill/>
+        </p:spPr>
+        <p:txBody>
+          <a:bodyPr wrap="square" lIns="0" rIns="0" tIns="0" bIns="0">
+            <a:spAutoFit/>
+          </a:bodyPr>
+          <a:lstStyle/>
+          <a:p>
+            <a:pPr algn="l"/>
+            <a:r>
+              <a:rPr sz="4400" b="1">
+                <a:solidFill>
+                  <a:srgbClr val="14213D"/>
+                </a:solidFill>
+                <a:latin typeface="Arial"/>
+              </a:rPr>
+              <a:t>$144,496</a:t>
+            </a:r>
+          </a:p>
+        </p:txBody>
+      </p:sp>
+      <p:sp>
+        <p:nvSpPr>
+          <p:cNvPr id="8" name="Stat Qualified Leads"/>
+          <p:cNvSpPr/>
+          <p:nvPr/>
+        </p:nvSpPr>
+        <p:spPr>
+          <a:xfrm>
+            <a:off x="4338218" y="1874519"/>
+            <a:ext cx="3515258" cy="1828800"/>
+          </a:xfrm>
+          <a:prstGeom prst="roundRect">
+            <a:avLst>
+              <a:gd name="adj" fmla="val 5000"/>
+            </a:avLst>
+          </a:prstGeom>
+          <a:solidFill>
+            <a:srgbClr val="FFFFFF"/>
+          </a:solidFill>
+          <a:ln w="9525">
+            <a:solidFill>
+              <a:srgbClr val="E2E0D8"/>
+            </a:solidFill>
+          </a:ln>
+        </p:spPr>
+        <p:style>
+          <a:lnRef idx="1">
+            <a:schemeClr val="accent1"/>
+          </a:lnRef>
+          <a:fillRef idx="3">
+            <a:schemeClr val="accent1"/>
+          </a:fillRef>
+          <a:effectRef idx="2">
+            <a:schemeClr val="accent1"/>
+          </a:effectRef>
+          <a:fontRef idx="minor">
+            <a:schemeClr val="lt1"/>
+          </a:fontRef>
+        </p:style>
+        <p:txBody>
+          <a:bodyPr rtlCol="0" anchor="ctr"/>
+          <a:lstStyle/>
+          <a:p>
+            <a:pPr algn="ctr"/>
+          </a:p>
+        </p:txBody>
+      </p:sp>
+      <p:sp>
+        <p:nvSpPr>
+          <p:cNvPr id="9" name="Text"/>
+          <p:cNvSpPr txBox="1"/>
+          <p:nvPr/>
+        </p:nvSpPr>
+        <p:spPr>
+          <a:xfrm>
+            <a:off x="4658258" y="2148839"/>
+            <a:ext cx="2875178" cy="274320"/>
+          </a:xfrm>
+          <a:prstGeom prst="rect">
+            <a:avLst/>
+          </a:prstGeom>
+          <a:noFill/>
+        </p:spPr>
+        <p:txBody>
+          <a:bodyPr wrap="square" lIns="0" rIns="0" tIns="0" bIns="0">
+            <a:spAutoFit/>
+          </a:bodyPr>
+          <a:lstStyle/>
+          <a:p>
+            <a:pPr algn="l"/>
+            <a:r>
+              <a:rPr sz="1200" b="1">
+                <a:solidFill>
+                  <a:srgbClr val="5A6478"/>
+                </a:solidFill>
+                <a:latin typeface="Arial"/>
+              </a:rPr>
+              <a:t>QUALIFIED LEADS</a:t>
+            </a:r>
+          </a:p>
+        </p:txBody>
+      </p:sp>
+      <p:sp>
+        <p:nvSpPr>
+          <p:cNvPr id="10" name="Text"/>
+          <p:cNvSpPr txBox="1"/>
+          <p:nvPr/>
+        </p:nvSpPr>
+        <p:spPr>
+          <a:xfrm>
+            <a:off x="4658258" y="2560320"/>
+            <a:ext cx="2875178" cy="822960"/>
+          </a:xfrm>
+          <a:prstGeom prst="rect">
+            <a:avLst/>
+          </a:prstGeom>
+          <a:noFill/>
+        </p:spPr>
+        <p:txBody>
+          <a:bodyPr wrap="square" lIns="0" rIns="0" tIns="0" bIns="0">
+            <a:spAutoFit/>
+          </a:bodyPr>
+          <a:lstStyle/>
+          <a:p>
+            <a:pPr algn="l"/>
+            <a:r>
+              <a:rPr sz="4400" b="1">
+                <a:solidFill>
+                  <a:srgbClr val="14213D"/>
+                </a:solidFill>
+                <a:latin typeface="Arial"/>
+              </a:rPr>
+              <a:t>969</a:t>
+            </a:r>
+          </a:p>
+        </p:txBody>
+      </p:sp>
+      <p:sp>
+        <p:nvSpPr>
+          <p:cNvPr id="11" name="Stat Cost Per Lead"/>
+          <p:cNvSpPr/>
+          <p:nvPr/>
+        </p:nvSpPr>
+        <p:spPr>
+          <a:xfrm>
+            <a:off x="8127796" y="1874519"/>
+            <a:ext cx="3515258" cy="1828800"/>
+          </a:xfrm>
+          <a:prstGeom prst="roundRect">
+            <a:avLst>
+              <a:gd name="adj" fmla="val 5000"/>
+            </a:avLst>
+          </a:prstGeom>
+          <a:solidFill>
+            <a:srgbClr val="FFFFFF"/>
+          </a:solidFill>
+          <a:ln w="9525">
+            <a:solidFill>
+              <a:srgbClr val="E2E0D8"/>
+            </a:solidFill>
+          </a:ln>
+        </p:spPr>
+        <p:style>
+          <a:lnRef idx="1">
+            <a:schemeClr val="accent1"/>
+          </a:lnRef>
+          <a:fillRef idx="3">
+            <a:schemeClr val="accent1"/>
+          </a:fillRef>
+          <a:effectRef idx="2">
+            <a:schemeClr val="accent1"/>
+          </a:effectRef>
+          <a:fontRef idx="minor">
+            <a:schemeClr val="lt1"/>
+          </a:fontRef>
+        </p:style>
+        <p:txBody>
+          <a:bodyPr rtlCol="0" anchor="ctr"/>
+          <a:lstStyle/>
+          <a:p>
+            <a:pPr algn="ctr"/>
+          </a:p>
+        </p:txBody>
+      </p:sp>
+      <p:sp>
+        <p:nvSpPr>
+          <p:cNvPr id="12" name="Text"/>
+          <p:cNvSpPr txBox="1"/>
+          <p:nvPr/>
+        </p:nvSpPr>
+        <p:spPr>
+          <a:xfrm>
+            <a:off x="8447836" y="2148839"/>
+            <a:ext cx="2875178" cy="274320"/>
+          </a:xfrm>
+          <a:prstGeom prst="rect">
+            <a:avLst/>
+          </a:prstGeom>
+          <a:noFill/>
+        </p:spPr>
+        <p:txBody>
+          <a:bodyPr wrap="square" lIns="0" rIns="0" tIns="0" bIns="0">
+            <a:spAutoFit/>
+          </a:bodyPr>
+          <a:lstStyle/>
+          <a:p>
+            <a:pPr algn="l"/>
+            <a:r>
+              <a:rPr sz="1200" b="1">
+                <a:solidFill>
+                  <a:srgbClr val="5A6478"/>
+                </a:solidFill>
+                <a:latin typeface="Arial"/>
+              </a:rPr>
+              <a:t>COST PER LEAD</a:t>
+            </a:r>
+          </a:p>
+        </p:txBody>
+      </p:sp>
+      <p:sp>
+        <p:nvSpPr>
+          <p:cNvPr id="13" name="Text"/>
+          <p:cNvSpPr txBox="1"/>
+          <p:nvPr/>
+        </p:nvSpPr>
+        <p:spPr>
+          <a:xfrm>
+            <a:off x="8447836" y="2560320"/>
+            <a:ext cx="2875178" cy="822960"/>
+          </a:xfrm>
+          <a:prstGeom prst="rect">
+            <a:avLst/>
+          </a:prstGeom>
+          <a:noFill/>
+        </p:spPr>
+        <p:txBody>
+          <a:bodyPr wrap="square" lIns="0" rIns="0" tIns="0" bIns="0">
+            <a:spAutoFit/>
+          </a:bodyPr>
+          <a:lstStyle/>
+          <a:p>
+            <a:pPr algn="l"/>
+            <a:r>
+              <a:rPr sz="4400" b="1">
+                <a:solidFill>
+                  <a:srgbClr val="14213D"/>
+                </a:solidFill>
+                <a:latin typeface="Arial"/>
+              </a:rPr>
+              <a:t>$149</a:t>
+            </a:r>
+          </a:p>
+        </p:txBody>
+      </p:sp>
+      <p:sp>
+        <p:nvSpPr>
+          <p:cNvPr id="14" name="Stat Booked Jobs"/>
+          <p:cNvSpPr/>
+          <p:nvPr/>
+        </p:nvSpPr>
+        <p:spPr>
+          <a:xfrm>
+            <a:off x="548640" y="3977639"/>
+            <a:ext cx="5410047" cy="1828800"/>
+          </a:xfrm>
+          <a:prstGeom prst="roundRect">
+            <a:avLst>
+              <a:gd name="adj" fmla="val 5000"/>
+            </a:avLst>
+          </a:prstGeom>
+          <a:solidFill>
+            <a:srgbClr val="14213D"/>
+          </a:solidFill>
+          <a:ln w="9525">
+            <a:solidFill>
+              <a:srgbClr val="14213D"/>
+            </a:solidFill>
+          </a:ln>
+        </p:spPr>
+        <p:style>
+          <a:lnRef idx="1">
+            <a:schemeClr val="accent1"/>
+          </a:lnRef>
+          <a:fillRef idx="3">
+            <a:schemeClr val="accent1"/>
+          </a:fillRef>
+          <a:effectRef idx="2">
+            <a:schemeClr val="accent1"/>
+          </a:effectRef>
+          <a:fontRef idx="minor">
+            <a:schemeClr val="lt1"/>
+          </a:fontRef>
+        </p:style>
+        <p:txBody>
+          <a:bodyPr rtlCol="0" anchor="ctr"/>
+          <a:lstStyle/>
+          <a:p>
+            <a:pPr algn="ctr"/>
+          </a:p>
+        </p:txBody>
+      </p:sp>
+      <p:sp>
+        <p:nvSpPr>
+          <p:cNvPr id="15" name="Text"/>
+          <p:cNvSpPr txBox="1"/>
+          <p:nvPr/>
+        </p:nvSpPr>
+        <p:spPr>
+          <a:xfrm>
+            <a:off x="868680" y="4251959"/>
+            <a:ext cx="4769967" cy="274320"/>
+          </a:xfrm>
+          <a:prstGeom prst="rect">
+            <a:avLst/>
+          </a:prstGeom>
+          <a:noFill/>
+        </p:spPr>
+        <p:txBody>
+          <a:bodyPr wrap="square" lIns="0" rIns="0" tIns="0" bIns="0">
+            <a:spAutoFit/>
+          </a:bodyPr>
+          <a:lstStyle/>
+          <a:p>
+            <a:pPr algn="l"/>
+            <a:r>
+              <a:rPr sz="1200" b="1">
+                <a:solidFill>
+                  <a:srgbClr val="C9D3E3"/>
+                </a:solidFill>
+                <a:latin typeface="Arial"/>
+              </a:rPr>
+              <a:t>BOOKED JOBS</a:t>
+            </a:r>
+          </a:p>
+        </p:txBody>
+      </p:sp>
+      <p:sp>
+        <p:nvSpPr>
+          <p:cNvPr id="16" name="Text"/>
+          <p:cNvSpPr txBox="1"/>
+          <p:nvPr/>
+        </p:nvSpPr>
+        <p:spPr>
+          <a:xfrm>
+            <a:off x="868680" y="4663440"/>
+            <a:ext cx="4769967" cy="822960"/>
+          </a:xfrm>
+          <a:prstGeom prst="rect">
+            <a:avLst/>
+          </a:prstGeom>
+          <a:noFill/>
+        </p:spPr>
+        <p:txBody>
+          <a:bodyPr wrap="square" lIns="0" rIns="0" tIns="0" bIns="0">
+            <a:spAutoFit/>
+          </a:bodyPr>
+          <a:lstStyle/>
+          <a:p>
+            <a:pPr algn="l"/>
+            <a:r>
+              <a:rPr sz="4400" b="1">
+                <a:solidFill>
+                  <a:srgbClr val="F7F6F2"/>
+                </a:solidFill>
+                <a:latin typeface="Arial"/>
+              </a:rPr>
+              <a:t>346</a:t>
+            </a:r>
+          </a:p>
+        </p:txBody>
+      </p:sp>
+      <p:sp>
+        <p:nvSpPr>
+          <p:cNvPr id="17" name="Stat Revenue"/>
+          <p:cNvSpPr/>
+          <p:nvPr/>
+        </p:nvSpPr>
+        <p:spPr>
+          <a:xfrm>
+            <a:off x="6233007" y="3977639"/>
+            <a:ext cx="5410047" cy="1828800"/>
+          </a:xfrm>
+          <a:prstGeom prst="roundRect">
+            <a:avLst>
+              <a:gd name="adj" fmla="val 5000"/>
+            </a:avLst>
+          </a:prstGeom>
+          <a:solidFill>
+            <a:srgbClr val="14213D"/>
+          </a:solidFill>
+          <a:ln w="9525">
+            <a:solidFill>
+              <a:srgbClr val="14213D"/>
+            </a:solidFill>
+          </a:ln>
+        </p:spPr>
+        <p:style>
+          <a:lnRef idx="1">
+            <a:schemeClr val="accent1"/>
+          </a:lnRef>
+          <a:fillRef idx="3">
+            <a:schemeClr val="accent1"/>
+          </a:fillRef>
+          <a:effectRef idx="2">
+            <a:schemeClr val="accent1"/>
+          </a:effectRef>
+          <a:fontRef idx="minor">
+            <a:schemeClr val="lt1"/>
+          </a:fontRef>
+        </p:style>
+        <p:txBody>
+          <a:bodyPr rtlCol="0" anchor="ctr"/>
+          <a:lstStyle/>
+          <a:p>
+            <a:pPr algn="ctr"/>
+          </a:p>
+        </p:txBody>
+      </p:sp>
+      <p:sp>
+        <p:nvSpPr>
+          <p:cNvPr id="18" name="Text"/>
+          <p:cNvSpPr txBox="1"/>
+          <p:nvPr/>
+        </p:nvSpPr>
+        <p:spPr>
+          <a:xfrm>
+            <a:off x="6553047" y="4251959"/>
+            <a:ext cx="4769967" cy="274320"/>
+          </a:xfrm>
+          <a:prstGeom prst="rect">
+            <a:avLst/>
+          </a:prstGeom>
+          <a:noFill/>
+        </p:spPr>
+        <p:txBody>
+          <a:bodyPr wrap="square" lIns="0" rIns="0" tIns="0" bIns="0">
+            <a:spAutoFit/>
+          </a:bodyPr>
+          <a:lstStyle/>
+          <a:p>
+            <a:pPr algn="l"/>
+            <a:r>
+              <a:rPr sz="1200" b="1">
+                <a:solidFill>
+                  <a:srgbClr val="C9D3E3"/>
+                </a:solidFill>
+                <a:latin typeface="Arial"/>
+              </a:rPr>
+              <a:t>REVENUE</a:t>
+            </a:r>
+          </a:p>
+        </p:txBody>
+      </p:sp>
+      <p:sp>
+        <p:nvSpPr>
+          <p:cNvPr id="19" name="Text"/>
+          <p:cNvSpPr txBox="1"/>
+          <p:nvPr/>
+        </p:nvSpPr>
+        <p:spPr>
+          <a:xfrm>
+            <a:off x="6553047" y="4663440"/>
+            <a:ext cx="4769967" cy="822960"/>
+          </a:xfrm>
+          <a:prstGeom prst="rect">
+            <a:avLst/>
+          </a:prstGeom>
+          <a:noFill/>
+        </p:spPr>
+        <p:txBody>
+          <a:bodyPr wrap="square" lIns="0" rIns="0" tIns="0" bIns="0">
+            <a:spAutoFit/>
+          </a:bodyPr>
+          <a:lstStyle/>
+          <a:p>
+            <a:pPr algn="l"/>
+            <a:r>
+              <a:rPr sz="4400" b="1">
+                <a:solidFill>
+                  <a:srgbClr val="F2A65A"/>
+                </a:solidFill>
+                <a:latin typeface="Arial"/>
+              </a:rPr>
+              <a:t>$244,807</a:t>
+            </a:r>
+          </a:p>
+        </p:txBody>
+      </p:sp>
+      <p:sp>
+        <p:nvSpPr>
+          <p:cNvPr id="20" name="Footer"/>
+          <p:cNvSpPr txBox="1"/>
+          <p:nvPr/>
+        </p:nvSpPr>
+        <p:spPr>
+          <a:xfrm>
+            <a:off x="548640" y="6355080"/>
+            <a:ext cx="10180015" cy="274320"/>
+          </a:xfrm>
+          <a:prstGeom prst="rect">
+            <a:avLst/>
+          </a:prstGeom>
+          <a:noFill/>
+        </p:spPr>
+        <p:txBody>
+          <a:bodyPr wrap="square" lIns="0" rIns="0" tIns="0" bIns="0">
+            <a:spAutoFit/>
+          </a:bodyPr>
+          <a:lstStyle/>
+          <a:p>
+            <a:pPr algn="l"/>
+            <a:r>
+              <a:rPr sz="1000" b="0">
+                <a:solidFill>
+                  <a:srgbClr val="5A6478"/>
+                </a:solidFill>
+                <a:latin typeface="Arial"/>
+              </a:rPr>
+              <a:t>Source: ROI Marketing, Charleston · April – September 2026 · figures as provided</a:t>
+            </a:r>
+          </a:p>
+        </p:txBody>
+      </p:sp>
+      <p:sp>
+        <p:nvSpPr>
+          <p:cNvPr id="21" name="Page number"/>
+          <p:cNvSpPr txBox="1"/>
+          <p:nvPr/>
+        </p:nvSpPr>
+        <p:spPr>
+          <a:xfrm>
+            <a:off x="11094415" y="6355080"/>
+            <a:ext cx="548640" cy="274320"/>
+          </a:xfrm>
+          <a:prstGeom prst="rect">
+            <a:avLst/>
+          </a:prstGeom>
+          <a:noFill/>
+        </p:spPr>
+        <p:txBody>
+          <a:bodyPr wrap="square" lIns="0" rIns="0" tIns="0" bIns="0">
+            <a:spAutoFit/>
+          </a:bodyPr>
+          <a:lstStyle/>
+          <a:p>
+            <a:pPr algn="r"/>
+            <a:r>
+              <a:rPr sz="1000" b="0">
+                <a:solidFill>
+                  <a:srgbClr val="5A6478"/>
+                </a:solidFill>
+                <a:latin typeface="Arial"/>
+              </a:rPr>
+              <a:t>5</a:t>
             </a:r>
           </a:p>
         </p:txBody>
@@ -21277,7 +22134,7 @@
                 </a:solidFill>
                 <a:latin typeface="Arial"/>
               </a:rPr>
-              <a:t>5</a:t>
+              <a:t>6</a:t>
             </a:r>
           </a:p>
         </p:txBody>
@@ -21408,7 +22265,7 @@
                 </a:solidFill>
                 <a:latin typeface="Arial"/>
               </a:rPr>
-              <a:t>6</a:t>
+              <a:t>7</a:t>
             </a:r>
           </a:p>
         </p:txBody>
@@ -22909,7 +23766,7 @@
                 </a:solidFill>
                 <a:latin typeface="Arial"/>
               </a:rPr>
-              <a:t>7</a:t>
+              <a:t>8</a:t>
             </a:r>
           </a:p>
         </p:txBody>
@@ -23499,7 +24356,7 @@
                 </a:solidFill>
                 <a:latin typeface="Arial"/>
               </a:rPr>
-              <a:t>8</a:t>
+              <a:t>9</a:t>
             </a:r>
           </a:p>
         </p:txBody>
@@ -24270,7 +25127,7 @@
                 </a:solidFill>
                 <a:latin typeface="Arial"/>
               </a:rPr>
-              <a:t>9</a:t>
+              <a:t>10</a:t>
             </a:r>
           </a:p>
         </p:txBody>

</xml_diff>